<commit_message>
Prepare repository documentation for final course submission
</commit_message>
<xml_diff>
--- a/CS341_Project_I_TaskTracker_Alexander_Goda_Amanda_Cabrera/docs/CS341_TaskTracker_Presentation.pptx
+++ b/CS341_Project_I_TaskTracker_Alexander_Goda_Amanda_Cabrera/docs/CS341_TaskTracker_Presentation.pptx
@@ -2,22 +2,22 @@
 <file path=ppt/presentation.xml><?xml version="1.0" encoding="utf-8"?>
 <p:presentation xmlns:p="http://schemas.openxmlformats.org/presentationml/2006/main">
   <p:sldMasterIdLst>
-    <p:sldMasterId xmlns:r="http://schemas.openxmlformats.org/officeDocument/2006/relationships" id="2147483648" r:id="R4f9f65c628684b1e"/>
+    <p:sldMasterId xmlns:r="http://schemas.openxmlformats.org/officeDocument/2006/relationships" id="2147483648" r:id="Rea1013ea654d4e29"/>
   </p:sldMasterIdLst>
   <p:notesMasterIdLst>
-    <p:notesMasterId xmlns:r="http://schemas.openxmlformats.org/officeDocument/2006/relationships" r:id="R0a6691a52eea41b9"/>
+    <p:notesMasterId xmlns:r="http://schemas.openxmlformats.org/officeDocument/2006/relationships" r:id="R7f35efcf1ef0471d"/>
   </p:notesMasterIdLst>
   <p:sldIdLst>
-    <p:sldId xmlns:r="http://schemas.openxmlformats.org/officeDocument/2006/relationships" id="256" r:id="R417ff0b292ee4eff"/>
-    <p:sldId xmlns:r="http://schemas.openxmlformats.org/officeDocument/2006/relationships" id="257" r:id="Rfb0d38ce9ed3430d"/>
-    <p:sldId xmlns:r="http://schemas.openxmlformats.org/officeDocument/2006/relationships" id="258" r:id="R36b44a8790f54621"/>
-    <p:sldId xmlns:r="http://schemas.openxmlformats.org/officeDocument/2006/relationships" id="259" r:id="R9018662c740f46bb"/>
-    <p:sldId xmlns:r="http://schemas.openxmlformats.org/officeDocument/2006/relationships" id="260" r:id="Raac3de7514b14984"/>
-    <p:sldId xmlns:r="http://schemas.openxmlformats.org/officeDocument/2006/relationships" id="261" r:id="R8464e036ae424ea9"/>
-    <p:sldId xmlns:r="http://schemas.openxmlformats.org/officeDocument/2006/relationships" id="262" r:id="R8fde0f3475e24354"/>
-    <p:sldId xmlns:r="http://schemas.openxmlformats.org/officeDocument/2006/relationships" id="263" r:id="Rb289a0e28e42495c"/>
-    <p:sldId xmlns:r="http://schemas.openxmlformats.org/officeDocument/2006/relationships" id="264" r:id="R9d87eb8326654347"/>
-    <p:sldId xmlns:r="http://schemas.openxmlformats.org/officeDocument/2006/relationships" id="265" r:id="R1d39de19be814070"/>
+    <p:sldId xmlns:r="http://schemas.openxmlformats.org/officeDocument/2006/relationships" id="256" r:id="R2ce0afd3b82941b6"/>
+    <p:sldId xmlns:r="http://schemas.openxmlformats.org/officeDocument/2006/relationships" id="257" r:id="Rfecba6da11d448ed"/>
+    <p:sldId xmlns:r="http://schemas.openxmlformats.org/officeDocument/2006/relationships" id="258" r:id="Rf5c4c197ef414005"/>
+    <p:sldId xmlns:r="http://schemas.openxmlformats.org/officeDocument/2006/relationships" id="259" r:id="Rd3aee4cc05dd4b3d"/>
+    <p:sldId xmlns:r="http://schemas.openxmlformats.org/officeDocument/2006/relationships" id="260" r:id="R5125acf2100a4307"/>
+    <p:sldId xmlns:r="http://schemas.openxmlformats.org/officeDocument/2006/relationships" id="261" r:id="Rebcae3deca9d4764"/>
+    <p:sldId xmlns:r="http://schemas.openxmlformats.org/officeDocument/2006/relationships" id="262" r:id="Rd05d9a05b0554959"/>
+    <p:sldId xmlns:r="http://schemas.openxmlformats.org/officeDocument/2006/relationships" id="263" r:id="Rec46264a35a343e2"/>
+    <p:sldId xmlns:r="http://schemas.openxmlformats.org/officeDocument/2006/relationships" id="264" r:id="R2ddab43a37ab438f"/>
+    <p:sldId xmlns:r="http://schemas.openxmlformats.org/officeDocument/2006/relationships" id="265" r:id="R06bfc81a1e3e4cb5"/>
   </p:sldIdLst>
   <p:sldSz cx="12192000" cy="6858000"/>
   <p:notesSz cx="6858000" cy="9144000"/>
@@ -451,7 +451,7 @@
           <a:lstStyle xmlns:a="http://schemas.openxmlformats.org/drawingml/2006/main"/>
           <a:p xmlns:a="http://schemas.openxmlformats.org/drawingml/2006/main">
             <a:r>
-              <a:t>Introduce the local desktop task manager. Both presenters should participate. Proposed timing for the deck and demo is 8–10 minutes, subject to the instructor’s actual time limit. Sources: project README and Requirements Analysis. This deck is prepared for team review and rehearsal.</a:t>
+              <a:t>Task Tracker is a standalone Java desktop application with local accounts and shared task data. Sources: README.md and the Requirements Analysis.</a:t>
             </a:r>
           </a:p>
         </p:txBody>
@@ -521,7 +521,7 @@
           <a:lstStyle xmlns:a="http://schemas.openxmlformats.org/drawingml/2006/main"/>
           <a:p xmlns:a="http://schemas.openxmlformats.org/drawingml/2006/main">
             <a:r>
-              <a:t>Keep scope honest: this is a local teaching project with unsalted SHA-256 credential hashing, fixed Swing layouts, and synchronous JDBC on GUI actions. No claim of exhaustive test coverage or a guaranteed rubric score. No Canvas upload has occurred. Source: docs/FINAL_SUBMISSION_CHECKLIST.md.</a:t>
+              <a:t>The local account model shares one SQLite file and does not synchronize across devices. The implementation uses unsalted SHA-256 hashes, fixed Swing layouts, and synchronous JDBC calls on the UI thread. Future improvements include salted adaptive password hashing, resizable layouts, and background database operations. The recorded tests cover representative workflows rather than exhaustive security, concurrency, or accessibility behavior. Sources: AuthController.java, the Swing views, and the Testing Report.</a:t>
             </a:r>
           </a:p>
         </p:txBody>
@@ -871,7 +871,7 @@
           <a:lstStyle xmlns:a="http://schemas.openxmlformats.org/drawingml/2006/main"/>
           <a:p xmlns:a="http://schemas.openxmlformats.org/drawingml/2006/main">
             <a:r>
-              <a:t>Fresh expanded suite: DatabaseManagerTest 2, UserDAOTest 5, TaskDAOTest 6, AuthControllerTest 6, TaskControllerTest 9. Problems tab displayed 0 items in its current configuration. Tests use temporary SQLite databases and include integration behavior. The earlier manual M01–M10 checks are historical evidence. Fresh manual GUI repetition could not be completed because automation could not bind to the Java window. Do not present 28 tests as GUI automation. Sources: docs/FINAL_AUDIT.md and testing report addendum.</a:t>
+              <a:t>The latest recorded October 16, 2026 suite passed 28/28 tests: DatabaseManagerTest 2, UserDAOTest 5, TaskDAOTest 6, AuthControllerTest 6, TaskControllerTest 9. The tests use temporary SQLite databases and exercise controllers and persistence. The ten manual M01–M10 checks are separate recorded evidence and were not repeated during that automated run. The suite does not automate Swing interaction. Source: the Testing Report and test/tester/.</a:t>
             </a:r>
           </a:p>
         </p:txBody>
@@ -1011,7 +1011,7 @@
           <a:lstStyle xmlns:a="http://schemas.openxmlformats.org/drawingml/2006/main"/>
           <a:p xmlns:a="http://schemas.openxmlformats.org/drawingml/2006/main">
             <a:r>
-              <a:t>Use docs/DEMO_SCRIPT.md for the complete sequence, unique demo accounts, validation cases, delete confirmation, cleanup, and fallback. Rehearse first. Proposed split: Alexander operates the first half and Amanda explains permissions and operates the assignee flow. This is a proposed division, not a record of completed rehearsal.</a:t>
+              <a:t>Demonstrate creator and assignee accounts: create an assigned task, show the assignee dashboard, attempt creator-only editing, complete and reopen the task, restart to show saved data, and log out with task editors open. Sources: TaskDashboardView.java, TaskController.java, and the Testing Report.</a:t>
             </a:r>
           </a:p>
         </p:txBody>
@@ -1081,7 +1081,7 @@
           <a:lstStyle xmlns:a="http://schemas.openxmlformats.org/drawingml/2006/main"/>
           <a:p xmlns:a="http://schemas.openxmlformats.org/drawingml/2006/main">
             <a:r>
-              <a:t>Amanda’s commit identity was verified in local Git and Safari on GitHub. GitHub Insights showed only Alexander during inspection and is not used as proof of absence or as a complete contribution measure. Do not claim equal commit counts. Confirm non-code contribution details with both team members. Sources: git log and https://github.com/alexandergoda/CS341-Project-I-TaskTracker-Alexander-Goda-Amanda-Cabrera/commit/63d8ae6</a:t>
+              <a:t>Amanda authored TaskController commit 63d8ae6, implementing task operations and permission checks. Alexander’s history includes integration, user interface, tests, and documentation. Commit counts alone do not capture all project work. Source: repository Git history and https://github.com/alexandergoda/CS341-Project-I-TaskTracker-Alexander-Goda-Amanda-Cabrera/commit/63d8ae6</a:t>
             </a:r>
           </a:p>
         </p:txBody>
@@ -3524,12 +3524,12 @@
   </p:cSld>
   <p:clrMap bg1="lt1" tx1="dk1" bg2="lt2" tx2="dk2" accent1="accent1" accent2="accent2" accent3="accent3" accent4="accent4" accent5="accent5" accent6="accent6" hlink="hlink" folHlink="folHlink"/>
   <p:sldLayoutIdLst>
-    <p:sldLayoutId xmlns:r="http://schemas.openxmlformats.org/officeDocument/2006/relationships" id="2147483649" r:id="Rca77a1c050c34477"/>
-    <p:sldLayoutId xmlns:r="http://schemas.openxmlformats.org/officeDocument/2006/relationships" id="2147483650" r:id="R34f43c2b1fd44d6a"/>
-    <p:sldLayoutId xmlns:r="http://schemas.openxmlformats.org/officeDocument/2006/relationships" id="2147483651" r:id="R996001e06a67490e"/>
-    <p:sldLayoutId xmlns:r="http://schemas.openxmlformats.org/officeDocument/2006/relationships" id="2147483652" r:id="R11cfe694be7d4235"/>
-    <p:sldLayoutId xmlns:r="http://schemas.openxmlformats.org/officeDocument/2006/relationships" id="2147483653" r:id="Ree7b2baf40a84c9e"/>
-    <p:sldLayoutId xmlns:r="http://schemas.openxmlformats.org/officeDocument/2006/relationships" id="2147483654" r:id="Rea47d3a8ef2c4dc0"/>
+    <p:sldLayoutId xmlns:r="http://schemas.openxmlformats.org/officeDocument/2006/relationships" id="2147483649" r:id="Rf940470b2a9040cf"/>
+    <p:sldLayoutId xmlns:r="http://schemas.openxmlformats.org/officeDocument/2006/relationships" id="2147483650" r:id="R5d3a723d8ec946e8"/>
+    <p:sldLayoutId xmlns:r="http://schemas.openxmlformats.org/officeDocument/2006/relationships" id="2147483651" r:id="Rf634a8d6e17645b2"/>
+    <p:sldLayoutId xmlns:r="http://schemas.openxmlformats.org/officeDocument/2006/relationships" id="2147483652" r:id="R7858d919f16544a9"/>
+    <p:sldLayoutId xmlns:r="http://schemas.openxmlformats.org/officeDocument/2006/relationships" id="2147483653" r:id="R006ed70e077646b3"/>
+    <p:sldLayoutId xmlns:r="http://schemas.openxmlformats.org/officeDocument/2006/relationships" id="2147483654" r:id="R719fac07346b451c"/>
   </p:sldLayoutIdLst>
   <p:txStyles>
     <p:titleStyle>
@@ -4116,6 +4116,7 @@
               </a:defRPr>
             </a:defPPr>
             <a:lvl1pPr>
+              <a:buNone/>
               <a:defRPr sz="4800" b="1">
                 <a:solidFill>
                   <a:srgbClr val="182431"/>
@@ -4126,6 +4127,7 @@
               </a:defRPr>
             </a:lvl1pPr>
             <a:lvl2pPr>
+              <a:buNone/>
               <a:defRPr sz="4800" b="1">
                 <a:solidFill>
                   <a:srgbClr val="182431"/>
@@ -4136,6 +4138,7 @@
               </a:defRPr>
             </a:lvl2pPr>
             <a:lvl3pPr>
+              <a:buNone/>
               <a:defRPr sz="4800" b="1">
                 <a:solidFill>
                   <a:srgbClr val="182431"/>
@@ -4146,6 +4149,7 @@
               </a:defRPr>
             </a:lvl3pPr>
             <a:lvl4pPr>
+              <a:buNone/>
               <a:defRPr sz="4800" b="1">
                 <a:solidFill>
                   <a:srgbClr val="182431"/>
@@ -4156,6 +4160,7 @@
               </a:defRPr>
             </a:lvl4pPr>
             <a:lvl5pPr>
+              <a:buNone/>
               <a:defRPr sz="4800" b="1">
                 <a:solidFill>
                   <a:srgbClr val="182431"/>
@@ -4166,6 +4171,7 @@
               </a:defRPr>
             </a:lvl5pPr>
             <a:lvl6pPr>
+              <a:buNone/>
               <a:defRPr sz="4800" b="1">
                 <a:solidFill>
                   <a:srgbClr val="182431"/>
@@ -4176,6 +4182,7 @@
               </a:defRPr>
             </a:lvl6pPr>
             <a:lvl7pPr>
+              <a:buNone/>
               <a:defRPr sz="4800" b="1">
                 <a:solidFill>
                   <a:srgbClr val="182431"/>
@@ -4186,6 +4193,7 @@
               </a:defRPr>
             </a:lvl7pPr>
             <a:lvl8pPr>
+              <a:buNone/>
               <a:defRPr sz="4800" b="1">
                 <a:solidFill>
                   <a:srgbClr val="182431"/>
@@ -4196,6 +4204,7 @@
               </a:defRPr>
             </a:lvl8pPr>
             <a:lvl9pPr>
+              <a:buNone/>
               <a:defRPr sz="4800" b="1">
                 <a:solidFill>
                   <a:srgbClr val="182431"/>
@@ -4208,6 +4217,7 @@
           </a:lstStyle>
           <a:p xmlns:a="http://schemas.openxmlformats.org/drawingml/2006/main">
             <a:pPr>
+              <a:buNone/>
               <a:defRPr sz="4800" b="1">
                 <a:solidFill>
                   <a:srgbClr val="182431"/>
@@ -4272,6 +4282,7 @@
               </a:defRPr>
             </a:defPPr>
             <a:lvl1pPr>
+              <a:buNone/>
               <a:defRPr sz="2550" b="0">
                 <a:solidFill>
                   <a:srgbClr val="182431"/>
@@ -4282,6 +4293,7 @@
               </a:defRPr>
             </a:lvl1pPr>
             <a:lvl2pPr>
+              <a:buNone/>
               <a:defRPr sz="2550" b="0">
                 <a:solidFill>
                   <a:srgbClr val="182431"/>
@@ -4292,6 +4304,7 @@
               </a:defRPr>
             </a:lvl2pPr>
             <a:lvl3pPr>
+              <a:buNone/>
               <a:defRPr sz="2550" b="0">
                 <a:solidFill>
                   <a:srgbClr val="182431"/>
@@ -4302,6 +4315,7 @@
               </a:defRPr>
             </a:lvl3pPr>
             <a:lvl4pPr>
+              <a:buNone/>
               <a:defRPr sz="2550" b="0">
                 <a:solidFill>
                   <a:srgbClr val="182431"/>
@@ -4312,6 +4326,7 @@
               </a:defRPr>
             </a:lvl4pPr>
             <a:lvl5pPr>
+              <a:buNone/>
               <a:defRPr sz="2550" b="0">
                 <a:solidFill>
                   <a:srgbClr val="182431"/>
@@ -4322,6 +4337,7 @@
               </a:defRPr>
             </a:lvl5pPr>
             <a:lvl6pPr>
+              <a:buNone/>
               <a:defRPr sz="2550" b="0">
                 <a:solidFill>
                   <a:srgbClr val="182431"/>
@@ -4332,6 +4348,7 @@
               </a:defRPr>
             </a:lvl6pPr>
             <a:lvl7pPr>
+              <a:buNone/>
               <a:defRPr sz="2550" b="0">
                 <a:solidFill>
                   <a:srgbClr val="182431"/>
@@ -4342,6 +4359,7 @@
               </a:defRPr>
             </a:lvl7pPr>
             <a:lvl8pPr>
+              <a:buNone/>
               <a:defRPr sz="2550" b="0">
                 <a:solidFill>
                   <a:srgbClr val="182431"/>
@@ -4352,6 +4370,7 @@
               </a:defRPr>
             </a:lvl8pPr>
             <a:lvl9pPr>
+              <a:buNone/>
               <a:defRPr sz="2550" b="0">
                 <a:solidFill>
                   <a:srgbClr val="182431"/>
@@ -4364,6 +4383,7 @@
           </a:lstStyle>
           <a:p xmlns:a="http://schemas.openxmlformats.org/drawingml/2006/main">
             <a:pPr>
+              <a:buNone/>
               <a:defRPr sz="2550" b="0">
                 <a:solidFill>
                   <a:srgbClr val="182431"/>
@@ -4428,6 +4448,7 @@
               </a:defRPr>
             </a:defPPr>
             <a:lvl1pPr>
+              <a:buNone/>
               <a:defRPr sz="2250" b="0">
                 <a:solidFill>
                   <a:srgbClr val="182431"/>
@@ -4438,6 +4459,7 @@
               </a:defRPr>
             </a:lvl1pPr>
             <a:lvl2pPr>
+              <a:buNone/>
               <a:defRPr sz="2250" b="0">
                 <a:solidFill>
                   <a:srgbClr val="182431"/>
@@ -4448,6 +4470,7 @@
               </a:defRPr>
             </a:lvl2pPr>
             <a:lvl3pPr>
+              <a:buNone/>
               <a:defRPr sz="2250" b="0">
                 <a:solidFill>
                   <a:srgbClr val="182431"/>
@@ -4458,6 +4481,7 @@
               </a:defRPr>
             </a:lvl3pPr>
             <a:lvl4pPr>
+              <a:buNone/>
               <a:defRPr sz="2250" b="0">
                 <a:solidFill>
                   <a:srgbClr val="182431"/>
@@ -4468,6 +4492,7 @@
               </a:defRPr>
             </a:lvl4pPr>
             <a:lvl5pPr>
+              <a:buNone/>
               <a:defRPr sz="2250" b="0">
                 <a:solidFill>
                   <a:srgbClr val="182431"/>
@@ -4478,6 +4503,7 @@
               </a:defRPr>
             </a:lvl5pPr>
             <a:lvl6pPr>
+              <a:buNone/>
               <a:defRPr sz="2250" b="0">
                 <a:solidFill>
                   <a:srgbClr val="182431"/>
@@ -4488,6 +4514,7 @@
               </a:defRPr>
             </a:lvl6pPr>
             <a:lvl7pPr>
+              <a:buNone/>
               <a:defRPr sz="2250" b="0">
                 <a:solidFill>
                   <a:srgbClr val="182431"/>
@@ -4498,6 +4525,7 @@
               </a:defRPr>
             </a:lvl7pPr>
             <a:lvl8pPr>
+              <a:buNone/>
               <a:defRPr sz="2250" b="0">
                 <a:solidFill>
                   <a:srgbClr val="182431"/>
@@ -4508,6 +4536,7 @@
               </a:defRPr>
             </a:lvl8pPr>
             <a:lvl9pPr>
+              <a:buNone/>
               <a:defRPr sz="2250" b="0">
                 <a:solidFill>
                   <a:srgbClr val="182431"/>
@@ -4520,6 +4549,7 @@
           </a:lstStyle>
           <a:p xmlns:a="http://schemas.openxmlformats.org/drawingml/2006/main">
             <a:pPr>
+              <a:buNone/>
               <a:defRPr sz="2250" b="0">
                 <a:solidFill>
                   <a:srgbClr val="182431"/>
@@ -4584,6 +4614,7 @@
               </a:defRPr>
             </a:defPPr>
             <a:lvl1pPr>
+              <a:buNone/>
               <a:defRPr sz="2025" b="0">
                 <a:solidFill>
                   <a:srgbClr val="182431"/>
@@ -4594,6 +4625,7 @@
               </a:defRPr>
             </a:lvl1pPr>
             <a:lvl2pPr>
+              <a:buNone/>
               <a:defRPr sz="2025" b="0">
                 <a:solidFill>
                   <a:srgbClr val="182431"/>
@@ -4604,6 +4636,7 @@
               </a:defRPr>
             </a:lvl2pPr>
             <a:lvl3pPr>
+              <a:buNone/>
               <a:defRPr sz="2025" b="0">
                 <a:solidFill>
                   <a:srgbClr val="182431"/>
@@ -4614,6 +4647,7 @@
               </a:defRPr>
             </a:lvl3pPr>
             <a:lvl4pPr>
+              <a:buNone/>
               <a:defRPr sz="2025" b="0">
                 <a:solidFill>
                   <a:srgbClr val="182431"/>
@@ -4624,6 +4658,7 @@
               </a:defRPr>
             </a:lvl4pPr>
             <a:lvl5pPr>
+              <a:buNone/>
               <a:defRPr sz="2025" b="0">
                 <a:solidFill>
                   <a:srgbClr val="182431"/>
@@ -4634,6 +4669,7 @@
               </a:defRPr>
             </a:lvl5pPr>
             <a:lvl6pPr>
+              <a:buNone/>
               <a:defRPr sz="2025" b="0">
                 <a:solidFill>
                   <a:srgbClr val="182431"/>
@@ -4644,6 +4680,7 @@
               </a:defRPr>
             </a:lvl6pPr>
             <a:lvl7pPr>
+              <a:buNone/>
               <a:defRPr sz="2025" b="0">
                 <a:solidFill>
                   <a:srgbClr val="182431"/>
@@ -4654,6 +4691,7 @@
               </a:defRPr>
             </a:lvl7pPr>
             <a:lvl8pPr>
+              <a:buNone/>
               <a:defRPr sz="2025" b="0">
                 <a:solidFill>
                   <a:srgbClr val="182431"/>
@@ -4664,6 +4702,7 @@
               </a:defRPr>
             </a:lvl8pPr>
             <a:lvl9pPr>
+              <a:buNone/>
               <a:defRPr sz="2025" b="0">
                 <a:solidFill>
                   <a:srgbClr val="182431"/>
@@ -4676,6 +4715,7 @@
           </a:lstStyle>
           <a:p xmlns:a="http://schemas.openxmlformats.org/drawingml/2006/main">
             <a:pPr>
+              <a:buNone/>
               <a:defRPr sz="2025" b="0">
                 <a:solidFill>
                   <a:srgbClr val="182431"/>
@@ -4769,6 +4809,7 @@
               </a:defRPr>
             </a:defPPr>
             <a:lvl1pPr>
+              <a:buNone/>
               <a:defRPr sz="3300" b="1">
                 <a:solidFill>
                   <a:srgbClr val="182431"/>
@@ -4779,6 +4820,7 @@
               </a:defRPr>
             </a:lvl1pPr>
             <a:lvl2pPr>
+              <a:buNone/>
               <a:defRPr sz="3300" b="1">
                 <a:solidFill>
                   <a:srgbClr val="182431"/>
@@ -4789,6 +4831,7 @@
               </a:defRPr>
             </a:lvl2pPr>
             <a:lvl3pPr>
+              <a:buNone/>
               <a:defRPr sz="3300" b="1">
                 <a:solidFill>
                   <a:srgbClr val="182431"/>
@@ -4799,6 +4842,7 @@
               </a:defRPr>
             </a:lvl3pPr>
             <a:lvl4pPr>
+              <a:buNone/>
               <a:defRPr sz="3300" b="1">
                 <a:solidFill>
                   <a:srgbClr val="182431"/>
@@ -4809,6 +4853,7 @@
               </a:defRPr>
             </a:lvl4pPr>
             <a:lvl5pPr>
+              <a:buNone/>
               <a:defRPr sz="3300" b="1">
                 <a:solidFill>
                   <a:srgbClr val="182431"/>
@@ -4819,6 +4864,7 @@
               </a:defRPr>
             </a:lvl5pPr>
             <a:lvl6pPr>
+              <a:buNone/>
               <a:defRPr sz="3300" b="1">
                 <a:solidFill>
                   <a:srgbClr val="182431"/>
@@ -4829,6 +4875,7 @@
               </a:defRPr>
             </a:lvl6pPr>
             <a:lvl7pPr>
+              <a:buNone/>
               <a:defRPr sz="3300" b="1">
                 <a:solidFill>
                   <a:srgbClr val="182431"/>
@@ -4839,6 +4886,7 @@
               </a:defRPr>
             </a:lvl7pPr>
             <a:lvl8pPr>
+              <a:buNone/>
               <a:defRPr sz="3300" b="1">
                 <a:solidFill>
                   <a:srgbClr val="182431"/>
@@ -4849,6 +4897,7 @@
               </a:defRPr>
             </a:lvl8pPr>
             <a:lvl9pPr>
+              <a:buNone/>
               <a:defRPr sz="3300" b="1">
                 <a:solidFill>
                   <a:srgbClr val="182431"/>
@@ -4861,6 +4910,7 @@
           </a:lstStyle>
           <a:p xmlns:a="http://schemas.openxmlformats.org/drawingml/2006/main">
             <a:pPr>
+              <a:buNone/>
               <a:defRPr sz="3300" b="1">
                 <a:solidFill>
                   <a:srgbClr val="182431"/>
@@ -4879,7 +4929,7 @@
                 <a:ea typeface="Arial"/>
                 <a:cs typeface="Arial"/>
               </a:rPr>
-              <a:t>Delivery readiness</a:t>
+              <a:t>Limitations and future improvements</a:t>
             </a:r>
           </a:p>
         </p:txBody>
@@ -4925,6 +4975,7 @@
               </a:defRPr>
             </a:defPPr>
             <a:lvl1pPr>
+              <a:buNone/>
               <a:defRPr sz="2250" b="0">
                 <a:solidFill>
                   <a:srgbClr val="182431"/>
@@ -4935,6 +4986,7 @@
               </a:defRPr>
             </a:lvl1pPr>
             <a:lvl2pPr>
+              <a:buNone/>
               <a:defRPr sz="2250" b="0">
                 <a:solidFill>
                   <a:srgbClr val="182431"/>
@@ -4945,6 +4997,7 @@
               </a:defRPr>
             </a:lvl2pPr>
             <a:lvl3pPr>
+              <a:buNone/>
               <a:defRPr sz="2250" b="0">
                 <a:solidFill>
                   <a:srgbClr val="182431"/>
@@ -4955,6 +5008,7 @@
               </a:defRPr>
             </a:lvl3pPr>
             <a:lvl4pPr>
+              <a:buNone/>
               <a:defRPr sz="2250" b="0">
                 <a:solidFill>
                   <a:srgbClr val="182431"/>
@@ -4965,6 +5019,7 @@
               </a:defRPr>
             </a:lvl4pPr>
             <a:lvl5pPr>
+              <a:buNone/>
               <a:defRPr sz="2250" b="0">
                 <a:solidFill>
                   <a:srgbClr val="182431"/>
@@ -4975,6 +5030,7 @@
               </a:defRPr>
             </a:lvl5pPr>
             <a:lvl6pPr>
+              <a:buNone/>
               <a:defRPr sz="2250" b="0">
                 <a:solidFill>
                   <a:srgbClr val="182431"/>
@@ -4985,6 +5041,7 @@
               </a:defRPr>
             </a:lvl6pPr>
             <a:lvl7pPr>
+              <a:buNone/>
               <a:defRPr sz="2250" b="0">
                 <a:solidFill>
                   <a:srgbClr val="182431"/>
@@ -4995,6 +5052,7 @@
               </a:defRPr>
             </a:lvl7pPr>
             <a:lvl8pPr>
+              <a:buNone/>
               <a:defRPr sz="2250" b="0">
                 <a:solidFill>
                   <a:srgbClr val="182431"/>
@@ -5005,6 +5063,7 @@
               </a:defRPr>
             </a:lvl8pPr>
             <a:lvl9pPr>
+              <a:buNone/>
               <a:defRPr sz="2250" b="0">
                 <a:solidFill>
                   <a:srgbClr val="182431"/>
@@ -5017,6 +5076,7 @@
           </a:lstStyle>
           <a:p xmlns:a="http://schemas.openxmlformats.org/drawingml/2006/main">
             <a:pPr>
+              <a:buNone/>
               <a:defRPr sz="2250" b="0">
                 <a:solidFill>
                   <a:srgbClr val="182431"/>
@@ -5035,7 +5095,7 @@
                 <a:ea typeface="Arial"/>
                 <a:cs typeface="Arial"/>
               </a:rPr>
-              <a:t>Core implementation and automated verification are ready.</a:t>
+              <a:t>The application shares one local SQLite database.</a:t>
             </a:r>
           </a:p>
         </p:txBody>
@@ -5081,6 +5141,7 @@
               </a:defRPr>
             </a:defPPr>
             <a:lvl1pPr>
+              <a:buNone/>
               <a:defRPr sz="2250" b="0">
                 <a:solidFill>
                   <a:srgbClr val="182431"/>
@@ -5091,6 +5152,7 @@
               </a:defRPr>
             </a:lvl1pPr>
             <a:lvl2pPr>
+              <a:buNone/>
               <a:defRPr sz="2250" b="0">
                 <a:solidFill>
                   <a:srgbClr val="182431"/>
@@ -5101,6 +5163,7 @@
               </a:defRPr>
             </a:lvl2pPr>
             <a:lvl3pPr>
+              <a:buNone/>
               <a:defRPr sz="2250" b="0">
                 <a:solidFill>
                   <a:srgbClr val="182431"/>
@@ -5111,6 +5174,7 @@
               </a:defRPr>
             </a:lvl3pPr>
             <a:lvl4pPr>
+              <a:buNone/>
               <a:defRPr sz="2250" b="0">
                 <a:solidFill>
                   <a:srgbClr val="182431"/>
@@ -5121,6 +5185,7 @@
               </a:defRPr>
             </a:lvl4pPr>
             <a:lvl5pPr>
+              <a:buNone/>
               <a:defRPr sz="2250" b="0">
                 <a:solidFill>
                   <a:srgbClr val="182431"/>
@@ -5131,6 +5196,7 @@
               </a:defRPr>
             </a:lvl5pPr>
             <a:lvl6pPr>
+              <a:buNone/>
               <a:defRPr sz="2250" b="0">
                 <a:solidFill>
                   <a:srgbClr val="182431"/>
@@ -5141,6 +5207,7 @@
               </a:defRPr>
             </a:lvl6pPr>
             <a:lvl7pPr>
+              <a:buNone/>
               <a:defRPr sz="2250" b="0">
                 <a:solidFill>
                   <a:srgbClr val="182431"/>
@@ -5151,6 +5218,7 @@
               </a:defRPr>
             </a:lvl7pPr>
             <a:lvl8pPr>
+              <a:buNone/>
               <a:defRPr sz="2250" b="0">
                 <a:solidFill>
                   <a:srgbClr val="182431"/>
@@ -5161,6 +5229,7 @@
               </a:defRPr>
             </a:lvl8pPr>
             <a:lvl9pPr>
+              <a:buNone/>
               <a:defRPr sz="2250" b="0">
                 <a:solidFill>
                   <a:srgbClr val="182431"/>
@@ -5173,6 +5242,7 @@
           </a:lstStyle>
           <a:p xmlns:a="http://schemas.openxmlformats.org/drawingml/2006/main">
             <a:pPr>
+              <a:buNone/>
               <a:defRPr sz="2250" b="0">
                 <a:solidFill>
                   <a:srgbClr val="182431"/>
@@ -5191,7 +5261,7 @@
                 <a:ea typeface="Arial"/>
                 <a:cs typeface="Arial"/>
               </a:rPr>
-              <a:t>Requirements, design, and testing documents are reconciled.</a:t>
+              <a:t>Password hashing uses unsalted SHA-256.</a:t>
             </a:r>
           </a:p>
         </p:txBody>
@@ -5237,6 +5307,7 @@
               </a:defRPr>
             </a:defPPr>
             <a:lvl1pPr>
+              <a:buNone/>
               <a:defRPr sz="2250" b="0">
                 <a:solidFill>
                   <a:srgbClr val="182431"/>
@@ -5247,6 +5318,7 @@
               </a:defRPr>
             </a:lvl1pPr>
             <a:lvl2pPr>
+              <a:buNone/>
               <a:defRPr sz="2250" b="0">
                 <a:solidFill>
                   <a:srgbClr val="182431"/>
@@ -5257,6 +5329,7 @@
               </a:defRPr>
             </a:lvl2pPr>
             <a:lvl3pPr>
+              <a:buNone/>
               <a:defRPr sz="2250" b="0">
                 <a:solidFill>
                   <a:srgbClr val="182431"/>
@@ -5267,6 +5340,7 @@
               </a:defRPr>
             </a:lvl3pPr>
             <a:lvl4pPr>
+              <a:buNone/>
               <a:defRPr sz="2250" b="0">
                 <a:solidFill>
                   <a:srgbClr val="182431"/>
@@ -5277,6 +5351,7 @@
               </a:defRPr>
             </a:lvl4pPr>
             <a:lvl5pPr>
+              <a:buNone/>
               <a:defRPr sz="2250" b="0">
                 <a:solidFill>
                   <a:srgbClr val="182431"/>
@@ -5287,6 +5362,7 @@
               </a:defRPr>
             </a:lvl5pPr>
             <a:lvl6pPr>
+              <a:buNone/>
               <a:defRPr sz="2250" b="0">
                 <a:solidFill>
                   <a:srgbClr val="182431"/>
@@ -5297,6 +5373,7 @@
               </a:defRPr>
             </a:lvl6pPr>
             <a:lvl7pPr>
+              <a:buNone/>
               <a:defRPr sz="2250" b="0">
                 <a:solidFill>
                   <a:srgbClr val="182431"/>
@@ -5307,6 +5384,7 @@
               </a:defRPr>
             </a:lvl7pPr>
             <a:lvl8pPr>
+              <a:buNone/>
               <a:defRPr sz="2250" b="0">
                 <a:solidFill>
                   <a:srgbClr val="182431"/>
@@ -5317,6 +5395,7 @@
               </a:defRPr>
             </a:lvl8pPr>
             <a:lvl9pPr>
+              <a:buNone/>
               <a:defRPr sz="2250" b="0">
                 <a:solidFill>
                   <a:srgbClr val="182431"/>
@@ -5329,6 +5408,7 @@
           </a:lstStyle>
           <a:p xmlns:a="http://schemas.openxmlformats.org/drawingml/2006/main">
             <a:pPr>
+              <a:buNone/>
               <a:defRPr sz="2250" b="0">
                 <a:solidFill>
                   <a:srgbClr val="182431"/>
@@ -5347,7 +5427,7 @@
                 <a:ea typeface="Arial"/>
                 <a:cs typeface="Arial"/>
               </a:rPr>
-              <a:t>Team review and a timed live rehearsal remain.</a:t>
+              <a:t>Swing layouts are fixed and JDBC runs on the UI thread.</a:t>
             </a:r>
           </a:p>
         </p:txBody>
@@ -5393,6 +5473,7 @@
               </a:defRPr>
             </a:defPPr>
             <a:lvl1pPr>
+              <a:buNone/>
               <a:defRPr sz="2250" b="0">
                 <a:solidFill>
                   <a:srgbClr val="182431"/>
@@ -5403,6 +5484,7 @@
               </a:defRPr>
             </a:lvl1pPr>
             <a:lvl2pPr>
+              <a:buNone/>
               <a:defRPr sz="2250" b="0">
                 <a:solidFill>
                   <a:srgbClr val="182431"/>
@@ -5413,6 +5495,7 @@
               </a:defRPr>
             </a:lvl2pPr>
             <a:lvl3pPr>
+              <a:buNone/>
               <a:defRPr sz="2250" b="0">
                 <a:solidFill>
                   <a:srgbClr val="182431"/>
@@ -5423,6 +5506,7 @@
               </a:defRPr>
             </a:lvl3pPr>
             <a:lvl4pPr>
+              <a:buNone/>
               <a:defRPr sz="2250" b="0">
                 <a:solidFill>
                   <a:srgbClr val="182431"/>
@@ -5433,6 +5517,7 @@
               </a:defRPr>
             </a:lvl4pPr>
             <a:lvl5pPr>
+              <a:buNone/>
               <a:defRPr sz="2250" b="0">
                 <a:solidFill>
                   <a:srgbClr val="182431"/>
@@ -5443,6 +5528,7 @@
               </a:defRPr>
             </a:lvl5pPr>
             <a:lvl6pPr>
+              <a:buNone/>
               <a:defRPr sz="2250" b="0">
                 <a:solidFill>
                   <a:srgbClr val="182431"/>
@@ -5453,6 +5539,7 @@
               </a:defRPr>
             </a:lvl6pPr>
             <a:lvl7pPr>
+              <a:buNone/>
               <a:defRPr sz="2250" b="0">
                 <a:solidFill>
                   <a:srgbClr val="182431"/>
@@ -5463,6 +5550,7 @@
               </a:defRPr>
             </a:lvl7pPr>
             <a:lvl8pPr>
+              <a:buNone/>
               <a:defRPr sz="2250" b="0">
                 <a:solidFill>
                   <a:srgbClr val="182431"/>
@@ -5473,6 +5561,7 @@
               </a:defRPr>
             </a:lvl8pPr>
             <a:lvl9pPr>
+              <a:buNone/>
               <a:defRPr sz="2250" b="0">
                 <a:solidFill>
                   <a:srgbClr val="182431"/>
@@ -5485,6 +5574,7 @@
           </a:lstStyle>
           <a:p xmlns:a="http://schemas.openxmlformats.org/drawingml/2006/main">
             <a:pPr>
+              <a:buNone/>
               <a:defRPr sz="2250" b="0">
                 <a:solidFill>
                   <a:srgbClr val="182431"/>
@@ -5503,7 +5593,7 @@
                 <a:ea typeface="Arial"/>
                 <a:cs typeface="Arial"/>
               </a:rPr>
-              <a:t>Confirm the exact Canvas files and deadline before uploading.</a:t>
+              <a:t>Future work: stronger password storage and responsive UI.</a:t>
             </a:r>
           </a:p>
         </p:txBody>
@@ -5578,6 +5668,7 @@
               </a:defRPr>
             </a:defPPr>
             <a:lvl1pPr>
+              <a:buNone/>
               <a:defRPr sz="3300" b="1">
                 <a:solidFill>
                   <a:srgbClr val="182431"/>
@@ -5588,6 +5679,7 @@
               </a:defRPr>
             </a:lvl1pPr>
             <a:lvl2pPr>
+              <a:buNone/>
               <a:defRPr sz="3300" b="1">
                 <a:solidFill>
                   <a:srgbClr val="182431"/>
@@ -5598,6 +5690,7 @@
               </a:defRPr>
             </a:lvl2pPr>
             <a:lvl3pPr>
+              <a:buNone/>
               <a:defRPr sz="3300" b="1">
                 <a:solidFill>
                   <a:srgbClr val="182431"/>
@@ -5608,6 +5701,7 @@
               </a:defRPr>
             </a:lvl3pPr>
             <a:lvl4pPr>
+              <a:buNone/>
               <a:defRPr sz="3300" b="1">
                 <a:solidFill>
                   <a:srgbClr val="182431"/>
@@ -5618,6 +5712,7 @@
               </a:defRPr>
             </a:lvl4pPr>
             <a:lvl5pPr>
+              <a:buNone/>
               <a:defRPr sz="3300" b="1">
                 <a:solidFill>
                   <a:srgbClr val="182431"/>
@@ -5628,6 +5723,7 @@
               </a:defRPr>
             </a:lvl5pPr>
             <a:lvl6pPr>
+              <a:buNone/>
               <a:defRPr sz="3300" b="1">
                 <a:solidFill>
                   <a:srgbClr val="182431"/>
@@ -5638,6 +5734,7 @@
               </a:defRPr>
             </a:lvl6pPr>
             <a:lvl7pPr>
+              <a:buNone/>
               <a:defRPr sz="3300" b="1">
                 <a:solidFill>
                   <a:srgbClr val="182431"/>
@@ -5648,6 +5745,7 @@
               </a:defRPr>
             </a:lvl7pPr>
             <a:lvl8pPr>
+              <a:buNone/>
               <a:defRPr sz="3300" b="1">
                 <a:solidFill>
                   <a:srgbClr val="182431"/>
@@ -5658,6 +5756,7 @@
               </a:defRPr>
             </a:lvl8pPr>
             <a:lvl9pPr>
+              <a:buNone/>
               <a:defRPr sz="3300" b="1">
                 <a:solidFill>
                   <a:srgbClr val="182431"/>
@@ -5670,6 +5769,7 @@
           </a:lstStyle>
           <a:p xmlns:a="http://schemas.openxmlformats.org/drawingml/2006/main">
             <a:pPr>
+              <a:buNone/>
               <a:defRPr sz="3300" b="1">
                 <a:solidFill>
                   <a:srgbClr val="182431"/>
@@ -5734,6 +5834,7 @@
               </a:defRPr>
             </a:defPPr>
             <a:lvl1pPr>
+              <a:buNone/>
               <a:defRPr sz="2250" b="0">
                 <a:solidFill>
                   <a:srgbClr val="182431"/>
@@ -5744,6 +5845,7 @@
               </a:defRPr>
             </a:lvl1pPr>
             <a:lvl2pPr>
+              <a:buNone/>
               <a:defRPr sz="2250" b="0">
                 <a:solidFill>
                   <a:srgbClr val="182431"/>
@@ -5754,6 +5856,7 @@
               </a:defRPr>
             </a:lvl2pPr>
             <a:lvl3pPr>
+              <a:buNone/>
               <a:defRPr sz="2250" b="0">
                 <a:solidFill>
                   <a:srgbClr val="182431"/>
@@ -5764,6 +5867,7 @@
               </a:defRPr>
             </a:lvl3pPr>
             <a:lvl4pPr>
+              <a:buNone/>
               <a:defRPr sz="2250" b="0">
                 <a:solidFill>
                   <a:srgbClr val="182431"/>
@@ -5774,6 +5878,7 @@
               </a:defRPr>
             </a:lvl4pPr>
             <a:lvl5pPr>
+              <a:buNone/>
               <a:defRPr sz="2250" b="0">
                 <a:solidFill>
                   <a:srgbClr val="182431"/>
@@ -5784,6 +5889,7 @@
               </a:defRPr>
             </a:lvl5pPr>
             <a:lvl6pPr>
+              <a:buNone/>
               <a:defRPr sz="2250" b="0">
                 <a:solidFill>
                   <a:srgbClr val="182431"/>
@@ -5794,6 +5900,7 @@
               </a:defRPr>
             </a:lvl6pPr>
             <a:lvl7pPr>
+              <a:buNone/>
               <a:defRPr sz="2250" b="0">
                 <a:solidFill>
                   <a:srgbClr val="182431"/>
@@ -5804,6 +5911,7 @@
               </a:defRPr>
             </a:lvl7pPr>
             <a:lvl8pPr>
+              <a:buNone/>
               <a:defRPr sz="2250" b="0">
                 <a:solidFill>
                   <a:srgbClr val="182431"/>
@@ -5814,6 +5922,7 @@
               </a:defRPr>
             </a:lvl8pPr>
             <a:lvl9pPr>
+              <a:buNone/>
               <a:defRPr sz="2250" b="0">
                 <a:solidFill>
                   <a:srgbClr val="182431"/>
@@ -5826,6 +5935,7 @@
           </a:lstStyle>
           <a:p xmlns:a="http://schemas.openxmlformats.org/drawingml/2006/main">
             <a:pPr>
+              <a:buNone/>
               <a:defRPr sz="2250" b="0">
                 <a:solidFill>
                   <a:srgbClr val="182431"/>
@@ -5890,6 +6000,7 @@
               </a:defRPr>
             </a:defPPr>
             <a:lvl1pPr>
+              <a:buNone/>
               <a:defRPr sz="2250" b="0">
                 <a:solidFill>
                   <a:srgbClr val="182431"/>
@@ -5900,6 +6011,7 @@
               </a:defRPr>
             </a:lvl1pPr>
             <a:lvl2pPr>
+              <a:buNone/>
               <a:defRPr sz="2250" b="0">
                 <a:solidFill>
                   <a:srgbClr val="182431"/>
@@ -5910,6 +6022,7 @@
               </a:defRPr>
             </a:lvl2pPr>
             <a:lvl3pPr>
+              <a:buNone/>
               <a:defRPr sz="2250" b="0">
                 <a:solidFill>
                   <a:srgbClr val="182431"/>
@@ -5920,6 +6033,7 @@
               </a:defRPr>
             </a:lvl3pPr>
             <a:lvl4pPr>
+              <a:buNone/>
               <a:defRPr sz="2250" b="0">
                 <a:solidFill>
                   <a:srgbClr val="182431"/>
@@ -5930,6 +6044,7 @@
               </a:defRPr>
             </a:lvl4pPr>
             <a:lvl5pPr>
+              <a:buNone/>
               <a:defRPr sz="2250" b="0">
                 <a:solidFill>
                   <a:srgbClr val="182431"/>
@@ -5940,6 +6055,7 @@
               </a:defRPr>
             </a:lvl5pPr>
             <a:lvl6pPr>
+              <a:buNone/>
               <a:defRPr sz="2250" b="0">
                 <a:solidFill>
                   <a:srgbClr val="182431"/>
@@ -5950,6 +6066,7 @@
               </a:defRPr>
             </a:lvl6pPr>
             <a:lvl7pPr>
+              <a:buNone/>
               <a:defRPr sz="2250" b="0">
                 <a:solidFill>
                   <a:srgbClr val="182431"/>
@@ -5960,6 +6077,7 @@
               </a:defRPr>
             </a:lvl7pPr>
             <a:lvl8pPr>
+              <a:buNone/>
               <a:defRPr sz="2250" b="0">
                 <a:solidFill>
                   <a:srgbClr val="182431"/>
@@ -5970,6 +6088,7 @@
               </a:defRPr>
             </a:lvl8pPr>
             <a:lvl9pPr>
+              <a:buNone/>
               <a:defRPr sz="2250" b="0">
                 <a:solidFill>
                   <a:srgbClr val="182431"/>
@@ -5982,6 +6101,7 @@
           </a:lstStyle>
           <a:p xmlns:a="http://schemas.openxmlformats.org/drawingml/2006/main">
             <a:pPr>
+              <a:buNone/>
               <a:defRPr sz="2250" b="0">
                 <a:solidFill>
                   <a:srgbClr val="182431"/>
@@ -6046,6 +6166,7 @@
               </a:defRPr>
             </a:defPPr>
             <a:lvl1pPr>
+              <a:buNone/>
               <a:defRPr sz="2250" b="0">
                 <a:solidFill>
                   <a:srgbClr val="182431"/>
@@ -6056,6 +6177,7 @@
               </a:defRPr>
             </a:lvl1pPr>
             <a:lvl2pPr>
+              <a:buNone/>
               <a:defRPr sz="2250" b="0">
                 <a:solidFill>
                   <a:srgbClr val="182431"/>
@@ -6066,6 +6188,7 @@
               </a:defRPr>
             </a:lvl2pPr>
             <a:lvl3pPr>
+              <a:buNone/>
               <a:defRPr sz="2250" b="0">
                 <a:solidFill>
                   <a:srgbClr val="182431"/>
@@ -6076,6 +6199,7 @@
               </a:defRPr>
             </a:lvl3pPr>
             <a:lvl4pPr>
+              <a:buNone/>
               <a:defRPr sz="2250" b="0">
                 <a:solidFill>
                   <a:srgbClr val="182431"/>
@@ -6086,6 +6210,7 @@
               </a:defRPr>
             </a:lvl4pPr>
             <a:lvl5pPr>
+              <a:buNone/>
               <a:defRPr sz="2250" b="0">
                 <a:solidFill>
                   <a:srgbClr val="182431"/>
@@ -6096,6 +6221,7 @@
               </a:defRPr>
             </a:lvl5pPr>
             <a:lvl6pPr>
+              <a:buNone/>
               <a:defRPr sz="2250" b="0">
                 <a:solidFill>
                   <a:srgbClr val="182431"/>
@@ -6106,6 +6232,7 @@
               </a:defRPr>
             </a:lvl6pPr>
             <a:lvl7pPr>
+              <a:buNone/>
               <a:defRPr sz="2250" b="0">
                 <a:solidFill>
                   <a:srgbClr val="182431"/>
@@ -6116,6 +6243,7 @@
               </a:defRPr>
             </a:lvl7pPr>
             <a:lvl8pPr>
+              <a:buNone/>
               <a:defRPr sz="2250" b="0">
                 <a:solidFill>
                   <a:srgbClr val="182431"/>
@@ -6126,6 +6254,7 @@
               </a:defRPr>
             </a:lvl8pPr>
             <a:lvl9pPr>
+              <a:buNone/>
               <a:defRPr sz="2250" b="0">
                 <a:solidFill>
                   <a:srgbClr val="182431"/>
@@ -6138,6 +6267,7 @@
           </a:lstStyle>
           <a:p xmlns:a="http://schemas.openxmlformats.org/drawingml/2006/main">
             <a:pPr>
+              <a:buNone/>
               <a:defRPr sz="2250" b="0">
                 <a:solidFill>
                   <a:srgbClr val="182431"/>
@@ -6202,6 +6332,7 @@
               </a:defRPr>
             </a:defPPr>
             <a:lvl1pPr>
+              <a:buNone/>
               <a:defRPr sz="2250" b="0">
                 <a:solidFill>
                   <a:srgbClr val="182431"/>
@@ -6212,6 +6343,7 @@
               </a:defRPr>
             </a:lvl1pPr>
             <a:lvl2pPr>
+              <a:buNone/>
               <a:defRPr sz="2250" b="0">
                 <a:solidFill>
                   <a:srgbClr val="182431"/>
@@ -6222,6 +6354,7 @@
               </a:defRPr>
             </a:lvl2pPr>
             <a:lvl3pPr>
+              <a:buNone/>
               <a:defRPr sz="2250" b="0">
                 <a:solidFill>
                   <a:srgbClr val="182431"/>
@@ -6232,6 +6365,7 @@
               </a:defRPr>
             </a:lvl3pPr>
             <a:lvl4pPr>
+              <a:buNone/>
               <a:defRPr sz="2250" b="0">
                 <a:solidFill>
                   <a:srgbClr val="182431"/>
@@ -6242,6 +6376,7 @@
               </a:defRPr>
             </a:lvl4pPr>
             <a:lvl5pPr>
+              <a:buNone/>
               <a:defRPr sz="2250" b="0">
                 <a:solidFill>
                   <a:srgbClr val="182431"/>
@@ -6252,6 +6387,7 @@
               </a:defRPr>
             </a:lvl5pPr>
             <a:lvl6pPr>
+              <a:buNone/>
               <a:defRPr sz="2250" b="0">
                 <a:solidFill>
                   <a:srgbClr val="182431"/>
@@ -6262,6 +6398,7 @@
               </a:defRPr>
             </a:lvl6pPr>
             <a:lvl7pPr>
+              <a:buNone/>
               <a:defRPr sz="2250" b="0">
                 <a:solidFill>
                   <a:srgbClr val="182431"/>
@@ -6272,6 +6409,7 @@
               </a:defRPr>
             </a:lvl7pPr>
             <a:lvl8pPr>
+              <a:buNone/>
               <a:defRPr sz="2250" b="0">
                 <a:solidFill>
                   <a:srgbClr val="182431"/>
@@ -6282,6 +6420,7 @@
               </a:defRPr>
             </a:lvl8pPr>
             <a:lvl9pPr>
+              <a:buNone/>
               <a:defRPr sz="2250" b="0">
                 <a:solidFill>
                   <a:srgbClr val="182431"/>
@@ -6294,6 +6433,7 @@
           </a:lstStyle>
           <a:p xmlns:a="http://schemas.openxmlformats.org/drawingml/2006/main">
             <a:pPr>
+              <a:buNone/>
               <a:defRPr sz="2250" b="0">
                 <a:solidFill>
                   <a:srgbClr val="182431"/>
@@ -6387,6 +6527,7 @@
               </a:defRPr>
             </a:defPPr>
             <a:lvl1pPr>
+              <a:buNone/>
               <a:defRPr sz="3300" b="1">
                 <a:solidFill>
                   <a:srgbClr val="182431"/>
@@ -6397,6 +6538,7 @@
               </a:defRPr>
             </a:lvl1pPr>
             <a:lvl2pPr>
+              <a:buNone/>
               <a:defRPr sz="3300" b="1">
                 <a:solidFill>
                   <a:srgbClr val="182431"/>
@@ -6407,6 +6549,7 @@
               </a:defRPr>
             </a:lvl2pPr>
             <a:lvl3pPr>
+              <a:buNone/>
               <a:defRPr sz="3300" b="1">
                 <a:solidFill>
                   <a:srgbClr val="182431"/>
@@ -6417,6 +6560,7 @@
               </a:defRPr>
             </a:lvl3pPr>
             <a:lvl4pPr>
+              <a:buNone/>
               <a:defRPr sz="3300" b="1">
                 <a:solidFill>
                   <a:srgbClr val="182431"/>
@@ -6427,6 +6571,7 @@
               </a:defRPr>
             </a:lvl4pPr>
             <a:lvl5pPr>
+              <a:buNone/>
               <a:defRPr sz="3300" b="1">
                 <a:solidFill>
                   <a:srgbClr val="182431"/>
@@ -6437,6 +6582,7 @@
               </a:defRPr>
             </a:lvl5pPr>
             <a:lvl6pPr>
+              <a:buNone/>
               <a:defRPr sz="3300" b="1">
                 <a:solidFill>
                   <a:srgbClr val="182431"/>
@@ -6447,6 +6593,7 @@
               </a:defRPr>
             </a:lvl6pPr>
             <a:lvl7pPr>
+              <a:buNone/>
               <a:defRPr sz="3300" b="1">
                 <a:solidFill>
                   <a:srgbClr val="182431"/>
@@ -6457,6 +6604,7 @@
               </a:defRPr>
             </a:lvl7pPr>
             <a:lvl8pPr>
+              <a:buNone/>
               <a:defRPr sz="3300" b="1">
                 <a:solidFill>
                   <a:srgbClr val="182431"/>
@@ -6467,6 +6615,7 @@
               </a:defRPr>
             </a:lvl8pPr>
             <a:lvl9pPr>
+              <a:buNone/>
               <a:defRPr sz="3300" b="1">
                 <a:solidFill>
                   <a:srgbClr val="182431"/>
@@ -6479,6 +6628,7 @@
           </a:lstStyle>
           <a:p xmlns:a="http://schemas.openxmlformats.org/drawingml/2006/main">
             <a:pPr>
+              <a:buNone/>
               <a:defRPr sz="3300" b="1">
                 <a:solidFill>
                   <a:srgbClr val="182431"/>
@@ -6507,7 +6657,7 @@
           <p:cNvPr id="2" name="">
             <a:extLst xmlns:a="http://schemas.openxmlformats.org/drawingml/2006/main">
               <a:ext uri="{FF2B5EF4-FFF2-40B4-BE49-F238E27FC236}">
-                <a16:creationId xmlns:a16="http://schemas.microsoft.com/office/drawing/2014/main" id="{D49FAD74-6233-4C34-BEAF-62C27F669127}"/>
+                <a16:creationId xmlns:a16="http://schemas.microsoft.com/office/drawing/2014/main" id="{C95AAF19-C09D-46AC-BC01-05362CE9FDAB}"/>
               </a:ext>
             </a:extLst>
           </p:cNvPr>
@@ -6517,7 +6667,7 @@
           <p:nvPr/>
         </p:nvPicPr>
         <p:blipFill>
-          <a:blip xmlns:r="http://schemas.openxmlformats.org/officeDocument/2006/relationships" xmlns:a="http://schemas.openxmlformats.org/drawingml/2006/main" r:embed="R140fe1d62fe64ec7"/>
+          <a:blip xmlns:r="http://schemas.openxmlformats.org/officeDocument/2006/relationships" xmlns:a="http://schemas.openxmlformats.org/drawingml/2006/main" r:embed="Rce1e23f4afa94a0e"/>
           <a:stretch xmlns:a="http://schemas.openxmlformats.org/drawingml/2006/main"/>
         </p:blipFill>
         <p:spPr>
@@ -6600,6 +6750,7 @@
               </a:defRPr>
             </a:defPPr>
             <a:lvl1pPr>
+              <a:buNone/>
               <a:defRPr sz="3300" b="1">
                 <a:solidFill>
                   <a:srgbClr val="182431"/>
@@ -6610,6 +6761,7 @@
               </a:defRPr>
             </a:lvl1pPr>
             <a:lvl2pPr>
+              <a:buNone/>
               <a:defRPr sz="3300" b="1">
                 <a:solidFill>
                   <a:srgbClr val="182431"/>
@@ -6620,6 +6772,7 @@
               </a:defRPr>
             </a:lvl2pPr>
             <a:lvl3pPr>
+              <a:buNone/>
               <a:defRPr sz="3300" b="1">
                 <a:solidFill>
                   <a:srgbClr val="182431"/>
@@ -6630,6 +6783,7 @@
               </a:defRPr>
             </a:lvl3pPr>
             <a:lvl4pPr>
+              <a:buNone/>
               <a:defRPr sz="3300" b="1">
                 <a:solidFill>
                   <a:srgbClr val="182431"/>
@@ -6640,6 +6794,7 @@
               </a:defRPr>
             </a:lvl4pPr>
             <a:lvl5pPr>
+              <a:buNone/>
               <a:defRPr sz="3300" b="1">
                 <a:solidFill>
                   <a:srgbClr val="182431"/>
@@ -6650,6 +6805,7 @@
               </a:defRPr>
             </a:lvl5pPr>
             <a:lvl6pPr>
+              <a:buNone/>
               <a:defRPr sz="3300" b="1">
                 <a:solidFill>
                   <a:srgbClr val="182431"/>
@@ -6660,6 +6816,7 @@
               </a:defRPr>
             </a:lvl6pPr>
             <a:lvl7pPr>
+              <a:buNone/>
               <a:defRPr sz="3300" b="1">
                 <a:solidFill>
                   <a:srgbClr val="182431"/>
@@ -6670,6 +6827,7 @@
               </a:defRPr>
             </a:lvl7pPr>
             <a:lvl8pPr>
+              <a:buNone/>
               <a:defRPr sz="3300" b="1">
                 <a:solidFill>
                   <a:srgbClr val="182431"/>
@@ -6680,6 +6838,7 @@
               </a:defRPr>
             </a:lvl8pPr>
             <a:lvl9pPr>
+              <a:buNone/>
               <a:defRPr sz="3300" b="1">
                 <a:solidFill>
                   <a:srgbClr val="182431"/>
@@ -6692,6 +6851,7 @@
           </a:lstStyle>
           <a:p xmlns:a="http://schemas.openxmlformats.org/drawingml/2006/main">
             <a:pPr>
+              <a:buNone/>
               <a:defRPr sz="3300" b="1">
                 <a:solidFill>
                   <a:srgbClr val="182431"/>
@@ -6720,7 +6880,7 @@
           <p:cNvPr id="2" name="">
             <a:extLst xmlns:a="http://schemas.openxmlformats.org/drawingml/2006/main">
               <a:ext uri="{FF2B5EF4-FFF2-40B4-BE49-F238E27FC236}">
-                <a16:creationId xmlns:a16="http://schemas.microsoft.com/office/drawing/2014/main" id="{1BF9D330-FFFC-4344-897D-73DD07311BF0}"/>
+                <a16:creationId xmlns:a16="http://schemas.microsoft.com/office/drawing/2014/main" id="{AAC1420D-9B1F-4F84-8058-B6C9D032A047}"/>
               </a:ext>
             </a:extLst>
           </p:cNvPr>
@@ -6730,7 +6890,7 @@
           <p:nvPr/>
         </p:nvPicPr>
         <p:blipFill>
-          <a:blip xmlns:r="http://schemas.openxmlformats.org/officeDocument/2006/relationships" xmlns:a="http://schemas.openxmlformats.org/drawingml/2006/main" r:embed="R86988d9804ee45a2"/>
+          <a:blip xmlns:r="http://schemas.openxmlformats.org/officeDocument/2006/relationships" xmlns:a="http://schemas.openxmlformats.org/drawingml/2006/main" r:embed="R4d20d126d9134195"/>
           <a:stretch xmlns:a="http://schemas.openxmlformats.org/drawingml/2006/main"/>
         </p:blipFill>
         <p:spPr>
@@ -6813,6 +6973,7 @@
               </a:defRPr>
             </a:defPPr>
             <a:lvl1pPr>
+              <a:buNone/>
               <a:defRPr sz="3300" b="1">
                 <a:solidFill>
                   <a:srgbClr val="182431"/>
@@ -6823,6 +6984,7 @@
               </a:defRPr>
             </a:lvl1pPr>
             <a:lvl2pPr>
+              <a:buNone/>
               <a:defRPr sz="3300" b="1">
                 <a:solidFill>
                   <a:srgbClr val="182431"/>
@@ -6833,6 +6995,7 @@
               </a:defRPr>
             </a:lvl2pPr>
             <a:lvl3pPr>
+              <a:buNone/>
               <a:defRPr sz="3300" b="1">
                 <a:solidFill>
                   <a:srgbClr val="182431"/>
@@ -6843,6 +7006,7 @@
               </a:defRPr>
             </a:lvl3pPr>
             <a:lvl4pPr>
+              <a:buNone/>
               <a:defRPr sz="3300" b="1">
                 <a:solidFill>
                   <a:srgbClr val="182431"/>
@@ -6853,6 +7017,7 @@
               </a:defRPr>
             </a:lvl4pPr>
             <a:lvl5pPr>
+              <a:buNone/>
               <a:defRPr sz="3300" b="1">
                 <a:solidFill>
                   <a:srgbClr val="182431"/>
@@ -6863,6 +7028,7 @@
               </a:defRPr>
             </a:lvl5pPr>
             <a:lvl6pPr>
+              <a:buNone/>
               <a:defRPr sz="3300" b="1">
                 <a:solidFill>
                   <a:srgbClr val="182431"/>
@@ -6873,6 +7039,7 @@
               </a:defRPr>
             </a:lvl6pPr>
             <a:lvl7pPr>
+              <a:buNone/>
               <a:defRPr sz="3300" b="1">
                 <a:solidFill>
                   <a:srgbClr val="182431"/>
@@ -6883,6 +7050,7 @@
               </a:defRPr>
             </a:lvl7pPr>
             <a:lvl8pPr>
+              <a:buNone/>
               <a:defRPr sz="3300" b="1">
                 <a:solidFill>
                   <a:srgbClr val="182431"/>
@@ -6893,6 +7061,7 @@
               </a:defRPr>
             </a:lvl8pPr>
             <a:lvl9pPr>
+              <a:buNone/>
               <a:defRPr sz="3300" b="1">
                 <a:solidFill>
                   <a:srgbClr val="182431"/>
@@ -6905,6 +7074,7 @@
           </a:lstStyle>
           <a:p xmlns:a="http://schemas.openxmlformats.org/drawingml/2006/main">
             <a:pPr>
+              <a:buNone/>
               <a:defRPr sz="3300" b="1">
                 <a:solidFill>
                   <a:srgbClr val="182431"/>
@@ -6969,6 +7139,7 @@
               </a:defRPr>
             </a:defPPr>
             <a:lvl1pPr>
+              <a:buNone/>
               <a:defRPr sz="2250" b="0">
                 <a:solidFill>
                   <a:srgbClr val="182431"/>
@@ -6979,6 +7150,7 @@
               </a:defRPr>
             </a:lvl1pPr>
             <a:lvl2pPr>
+              <a:buNone/>
               <a:defRPr sz="2250" b="0">
                 <a:solidFill>
                   <a:srgbClr val="182431"/>
@@ -6989,6 +7161,7 @@
               </a:defRPr>
             </a:lvl2pPr>
             <a:lvl3pPr>
+              <a:buNone/>
               <a:defRPr sz="2250" b="0">
                 <a:solidFill>
                   <a:srgbClr val="182431"/>
@@ -6999,6 +7172,7 @@
               </a:defRPr>
             </a:lvl3pPr>
             <a:lvl4pPr>
+              <a:buNone/>
               <a:defRPr sz="2250" b="0">
                 <a:solidFill>
                   <a:srgbClr val="182431"/>
@@ -7009,6 +7183,7 @@
               </a:defRPr>
             </a:lvl4pPr>
             <a:lvl5pPr>
+              <a:buNone/>
               <a:defRPr sz="2250" b="0">
                 <a:solidFill>
                   <a:srgbClr val="182431"/>
@@ -7019,6 +7194,7 @@
               </a:defRPr>
             </a:lvl5pPr>
             <a:lvl6pPr>
+              <a:buNone/>
               <a:defRPr sz="2250" b="0">
                 <a:solidFill>
                   <a:srgbClr val="182431"/>
@@ -7029,6 +7205,7 @@
               </a:defRPr>
             </a:lvl6pPr>
             <a:lvl7pPr>
+              <a:buNone/>
               <a:defRPr sz="2250" b="0">
                 <a:solidFill>
                   <a:srgbClr val="182431"/>
@@ -7039,6 +7216,7 @@
               </a:defRPr>
             </a:lvl7pPr>
             <a:lvl8pPr>
+              <a:buNone/>
               <a:defRPr sz="2250" b="0">
                 <a:solidFill>
                   <a:srgbClr val="182431"/>
@@ -7049,6 +7227,7 @@
               </a:defRPr>
             </a:lvl8pPr>
             <a:lvl9pPr>
+              <a:buNone/>
               <a:defRPr sz="2250" b="0">
                 <a:solidFill>
                   <a:srgbClr val="182431"/>
@@ -7061,6 +7240,7 @@
           </a:lstStyle>
           <a:p xmlns:a="http://schemas.openxmlformats.org/drawingml/2006/main">
             <a:pPr>
+              <a:buNone/>
               <a:defRPr sz="2250" b="0">
                 <a:solidFill>
                   <a:srgbClr val="182431"/>
@@ -7125,6 +7305,7 @@
               </a:defRPr>
             </a:defPPr>
             <a:lvl1pPr>
+              <a:buNone/>
               <a:defRPr sz="2250" b="0">
                 <a:solidFill>
                   <a:srgbClr val="182431"/>
@@ -7135,6 +7316,7 @@
               </a:defRPr>
             </a:lvl1pPr>
             <a:lvl2pPr>
+              <a:buNone/>
               <a:defRPr sz="2250" b="0">
                 <a:solidFill>
                   <a:srgbClr val="182431"/>
@@ -7145,6 +7327,7 @@
               </a:defRPr>
             </a:lvl2pPr>
             <a:lvl3pPr>
+              <a:buNone/>
               <a:defRPr sz="2250" b="0">
                 <a:solidFill>
                   <a:srgbClr val="182431"/>
@@ -7155,6 +7338,7 @@
               </a:defRPr>
             </a:lvl3pPr>
             <a:lvl4pPr>
+              <a:buNone/>
               <a:defRPr sz="2250" b="0">
                 <a:solidFill>
                   <a:srgbClr val="182431"/>
@@ -7165,6 +7349,7 @@
               </a:defRPr>
             </a:lvl4pPr>
             <a:lvl5pPr>
+              <a:buNone/>
               <a:defRPr sz="2250" b="0">
                 <a:solidFill>
                   <a:srgbClr val="182431"/>
@@ -7175,6 +7360,7 @@
               </a:defRPr>
             </a:lvl5pPr>
             <a:lvl6pPr>
+              <a:buNone/>
               <a:defRPr sz="2250" b="0">
                 <a:solidFill>
                   <a:srgbClr val="182431"/>
@@ -7185,6 +7371,7 @@
               </a:defRPr>
             </a:lvl6pPr>
             <a:lvl7pPr>
+              <a:buNone/>
               <a:defRPr sz="2250" b="0">
                 <a:solidFill>
                   <a:srgbClr val="182431"/>
@@ -7195,6 +7382,7 @@
               </a:defRPr>
             </a:lvl7pPr>
             <a:lvl8pPr>
+              <a:buNone/>
               <a:defRPr sz="2250" b="0">
                 <a:solidFill>
                   <a:srgbClr val="182431"/>
@@ -7205,6 +7393,7 @@
               </a:defRPr>
             </a:lvl8pPr>
             <a:lvl9pPr>
+              <a:buNone/>
               <a:defRPr sz="2250" b="0">
                 <a:solidFill>
                   <a:srgbClr val="182431"/>
@@ -7217,6 +7406,7 @@
           </a:lstStyle>
           <a:p xmlns:a="http://schemas.openxmlformats.org/drawingml/2006/main">
             <a:pPr>
+              <a:buNone/>
               <a:defRPr sz="2250" b="0">
                 <a:solidFill>
                   <a:srgbClr val="182431"/>
@@ -7281,6 +7471,7 @@
               </a:defRPr>
             </a:defPPr>
             <a:lvl1pPr>
+              <a:buNone/>
               <a:defRPr sz="2250" b="0">
                 <a:solidFill>
                   <a:srgbClr val="182431"/>
@@ -7291,6 +7482,7 @@
               </a:defRPr>
             </a:lvl1pPr>
             <a:lvl2pPr>
+              <a:buNone/>
               <a:defRPr sz="2250" b="0">
                 <a:solidFill>
                   <a:srgbClr val="182431"/>
@@ -7301,6 +7493,7 @@
               </a:defRPr>
             </a:lvl2pPr>
             <a:lvl3pPr>
+              <a:buNone/>
               <a:defRPr sz="2250" b="0">
                 <a:solidFill>
                   <a:srgbClr val="182431"/>
@@ -7311,6 +7504,7 @@
               </a:defRPr>
             </a:lvl3pPr>
             <a:lvl4pPr>
+              <a:buNone/>
               <a:defRPr sz="2250" b="0">
                 <a:solidFill>
                   <a:srgbClr val="182431"/>
@@ -7321,6 +7515,7 @@
               </a:defRPr>
             </a:lvl4pPr>
             <a:lvl5pPr>
+              <a:buNone/>
               <a:defRPr sz="2250" b="0">
                 <a:solidFill>
                   <a:srgbClr val="182431"/>
@@ -7331,6 +7526,7 @@
               </a:defRPr>
             </a:lvl5pPr>
             <a:lvl6pPr>
+              <a:buNone/>
               <a:defRPr sz="2250" b="0">
                 <a:solidFill>
                   <a:srgbClr val="182431"/>
@@ -7341,6 +7537,7 @@
               </a:defRPr>
             </a:lvl6pPr>
             <a:lvl7pPr>
+              <a:buNone/>
               <a:defRPr sz="2250" b="0">
                 <a:solidFill>
                   <a:srgbClr val="182431"/>
@@ -7351,6 +7548,7 @@
               </a:defRPr>
             </a:lvl7pPr>
             <a:lvl8pPr>
+              <a:buNone/>
               <a:defRPr sz="2250" b="0">
                 <a:solidFill>
                   <a:srgbClr val="182431"/>
@@ -7361,6 +7559,7 @@
               </a:defRPr>
             </a:lvl8pPr>
             <a:lvl9pPr>
+              <a:buNone/>
               <a:defRPr sz="2250" b="0">
                 <a:solidFill>
                   <a:srgbClr val="182431"/>
@@ -7373,6 +7572,7 @@
           </a:lstStyle>
           <a:p xmlns:a="http://schemas.openxmlformats.org/drawingml/2006/main">
             <a:pPr>
+              <a:buNone/>
               <a:defRPr sz="2250" b="0">
                 <a:solidFill>
                   <a:srgbClr val="182431"/>
@@ -7437,6 +7637,7 @@
               </a:defRPr>
             </a:defPPr>
             <a:lvl1pPr>
+              <a:buNone/>
               <a:defRPr sz="2250" b="0">
                 <a:solidFill>
                   <a:srgbClr val="182431"/>
@@ -7447,6 +7648,7 @@
               </a:defRPr>
             </a:lvl1pPr>
             <a:lvl2pPr>
+              <a:buNone/>
               <a:defRPr sz="2250" b="0">
                 <a:solidFill>
                   <a:srgbClr val="182431"/>
@@ -7457,6 +7659,7 @@
               </a:defRPr>
             </a:lvl2pPr>
             <a:lvl3pPr>
+              <a:buNone/>
               <a:defRPr sz="2250" b="0">
                 <a:solidFill>
                   <a:srgbClr val="182431"/>
@@ -7467,6 +7670,7 @@
               </a:defRPr>
             </a:lvl3pPr>
             <a:lvl4pPr>
+              <a:buNone/>
               <a:defRPr sz="2250" b="0">
                 <a:solidFill>
                   <a:srgbClr val="182431"/>
@@ -7477,6 +7681,7 @@
               </a:defRPr>
             </a:lvl4pPr>
             <a:lvl5pPr>
+              <a:buNone/>
               <a:defRPr sz="2250" b="0">
                 <a:solidFill>
                   <a:srgbClr val="182431"/>
@@ -7487,6 +7692,7 @@
               </a:defRPr>
             </a:lvl5pPr>
             <a:lvl6pPr>
+              <a:buNone/>
               <a:defRPr sz="2250" b="0">
                 <a:solidFill>
                   <a:srgbClr val="182431"/>
@@ -7497,6 +7703,7 @@
               </a:defRPr>
             </a:lvl6pPr>
             <a:lvl7pPr>
+              <a:buNone/>
               <a:defRPr sz="2250" b="0">
                 <a:solidFill>
                   <a:srgbClr val="182431"/>
@@ -7507,6 +7714,7 @@
               </a:defRPr>
             </a:lvl7pPr>
             <a:lvl8pPr>
+              <a:buNone/>
               <a:defRPr sz="2250" b="0">
                 <a:solidFill>
                   <a:srgbClr val="182431"/>
@@ -7517,6 +7725,7 @@
               </a:defRPr>
             </a:lvl8pPr>
             <a:lvl9pPr>
+              <a:buNone/>
               <a:defRPr sz="2250" b="0">
                 <a:solidFill>
                   <a:srgbClr val="182431"/>
@@ -7529,6 +7738,7 @@
           </a:lstStyle>
           <a:p xmlns:a="http://schemas.openxmlformats.org/drawingml/2006/main">
             <a:pPr>
+              <a:buNone/>
               <a:defRPr sz="2250" b="0">
                 <a:solidFill>
                   <a:srgbClr val="182431"/>
@@ -7622,6 +7832,7 @@
               </a:defRPr>
             </a:defPPr>
             <a:lvl1pPr>
+              <a:buNone/>
               <a:defRPr sz="3300" b="1">
                 <a:solidFill>
                   <a:srgbClr val="182431"/>
@@ -7632,6 +7843,7 @@
               </a:defRPr>
             </a:lvl1pPr>
             <a:lvl2pPr>
+              <a:buNone/>
               <a:defRPr sz="3300" b="1">
                 <a:solidFill>
                   <a:srgbClr val="182431"/>
@@ -7642,6 +7854,7 @@
               </a:defRPr>
             </a:lvl2pPr>
             <a:lvl3pPr>
+              <a:buNone/>
               <a:defRPr sz="3300" b="1">
                 <a:solidFill>
                   <a:srgbClr val="182431"/>
@@ -7652,6 +7865,7 @@
               </a:defRPr>
             </a:lvl3pPr>
             <a:lvl4pPr>
+              <a:buNone/>
               <a:defRPr sz="3300" b="1">
                 <a:solidFill>
                   <a:srgbClr val="182431"/>
@@ -7662,6 +7876,7 @@
               </a:defRPr>
             </a:lvl4pPr>
             <a:lvl5pPr>
+              <a:buNone/>
               <a:defRPr sz="3300" b="1">
                 <a:solidFill>
                   <a:srgbClr val="182431"/>
@@ -7672,6 +7887,7 @@
               </a:defRPr>
             </a:lvl5pPr>
             <a:lvl6pPr>
+              <a:buNone/>
               <a:defRPr sz="3300" b="1">
                 <a:solidFill>
                   <a:srgbClr val="182431"/>
@@ -7682,6 +7898,7 @@
               </a:defRPr>
             </a:lvl6pPr>
             <a:lvl7pPr>
+              <a:buNone/>
               <a:defRPr sz="3300" b="1">
                 <a:solidFill>
                   <a:srgbClr val="182431"/>
@@ -7692,6 +7909,7 @@
               </a:defRPr>
             </a:lvl7pPr>
             <a:lvl8pPr>
+              <a:buNone/>
               <a:defRPr sz="3300" b="1">
                 <a:solidFill>
                   <a:srgbClr val="182431"/>
@@ -7702,6 +7920,7 @@
               </a:defRPr>
             </a:lvl8pPr>
             <a:lvl9pPr>
+              <a:buNone/>
               <a:defRPr sz="3300" b="1">
                 <a:solidFill>
                   <a:srgbClr val="182431"/>
@@ -7714,6 +7933,7 @@
           </a:lstStyle>
           <a:p xmlns:a="http://schemas.openxmlformats.org/drawingml/2006/main">
             <a:pPr>
+              <a:buNone/>
               <a:defRPr sz="3300" b="1">
                 <a:solidFill>
                   <a:srgbClr val="182431"/>
@@ -7778,6 +7998,7 @@
               </a:defRPr>
             </a:defPPr>
             <a:lvl1pPr>
+              <a:buNone/>
               <a:defRPr sz="2250" b="0">
                 <a:solidFill>
                   <a:srgbClr val="182431"/>
@@ -7788,6 +8009,7 @@
               </a:defRPr>
             </a:lvl1pPr>
             <a:lvl2pPr>
+              <a:buNone/>
               <a:defRPr sz="2250" b="0">
                 <a:solidFill>
                   <a:srgbClr val="182431"/>
@@ -7798,6 +8020,7 @@
               </a:defRPr>
             </a:lvl2pPr>
             <a:lvl3pPr>
+              <a:buNone/>
               <a:defRPr sz="2250" b="0">
                 <a:solidFill>
                   <a:srgbClr val="182431"/>
@@ -7808,6 +8031,7 @@
               </a:defRPr>
             </a:lvl3pPr>
             <a:lvl4pPr>
+              <a:buNone/>
               <a:defRPr sz="2250" b="0">
                 <a:solidFill>
                   <a:srgbClr val="182431"/>
@@ -7818,6 +8042,7 @@
               </a:defRPr>
             </a:lvl4pPr>
             <a:lvl5pPr>
+              <a:buNone/>
               <a:defRPr sz="2250" b="0">
                 <a:solidFill>
                   <a:srgbClr val="182431"/>
@@ -7828,6 +8053,7 @@
               </a:defRPr>
             </a:lvl5pPr>
             <a:lvl6pPr>
+              <a:buNone/>
               <a:defRPr sz="2250" b="0">
                 <a:solidFill>
                   <a:srgbClr val="182431"/>
@@ -7838,6 +8064,7 @@
               </a:defRPr>
             </a:lvl6pPr>
             <a:lvl7pPr>
+              <a:buNone/>
               <a:defRPr sz="2250" b="0">
                 <a:solidFill>
                   <a:srgbClr val="182431"/>
@@ -7848,6 +8075,7 @@
               </a:defRPr>
             </a:lvl7pPr>
             <a:lvl8pPr>
+              <a:buNone/>
               <a:defRPr sz="2250" b="0">
                 <a:solidFill>
                   <a:srgbClr val="182431"/>
@@ -7858,6 +8086,7 @@
               </a:defRPr>
             </a:lvl8pPr>
             <a:lvl9pPr>
+              <a:buNone/>
               <a:defRPr sz="2250" b="0">
                 <a:solidFill>
                   <a:srgbClr val="182431"/>
@@ -7870,6 +8099,7 @@
           </a:lstStyle>
           <a:p xmlns:a="http://schemas.openxmlformats.org/drawingml/2006/main">
             <a:pPr>
+              <a:buNone/>
               <a:defRPr sz="2250" b="0">
                 <a:solidFill>
                   <a:srgbClr val="182431"/>
@@ -7934,6 +8164,7 @@
               </a:defRPr>
             </a:defPPr>
             <a:lvl1pPr>
+              <a:buNone/>
               <a:defRPr sz="2250" b="0">
                 <a:solidFill>
                   <a:srgbClr val="182431"/>
@@ -7944,6 +8175,7 @@
               </a:defRPr>
             </a:lvl1pPr>
             <a:lvl2pPr>
+              <a:buNone/>
               <a:defRPr sz="2250" b="0">
                 <a:solidFill>
                   <a:srgbClr val="182431"/>
@@ -7954,6 +8186,7 @@
               </a:defRPr>
             </a:lvl2pPr>
             <a:lvl3pPr>
+              <a:buNone/>
               <a:defRPr sz="2250" b="0">
                 <a:solidFill>
                   <a:srgbClr val="182431"/>
@@ -7964,6 +8197,7 @@
               </a:defRPr>
             </a:lvl3pPr>
             <a:lvl4pPr>
+              <a:buNone/>
               <a:defRPr sz="2250" b="0">
                 <a:solidFill>
                   <a:srgbClr val="182431"/>
@@ -7974,6 +8208,7 @@
               </a:defRPr>
             </a:lvl4pPr>
             <a:lvl5pPr>
+              <a:buNone/>
               <a:defRPr sz="2250" b="0">
                 <a:solidFill>
                   <a:srgbClr val="182431"/>
@@ -7984,6 +8219,7 @@
               </a:defRPr>
             </a:lvl5pPr>
             <a:lvl6pPr>
+              <a:buNone/>
               <a:defRPr sz="2250" b="0">
                 <a:solidFill>
                   <a:srgbClr val="182431"/>
@@ -7994,6 +8230,7 @@
               </a:defRPr>
             </a:lvl6pPr>
             <a:lvl7pPr>
+              <a:buNone/>
               <a:defRPr sz="2250" b="0">
                 <a:solidFill>
                   <a:srgbClr val="182431"/>
@@ -8004,6 +8241,7 @@
               </a:defRPr>
             </a:lvl7pPr>
             <a:lvl8pPr>
+              <a:buNone/>
               <a:defRPr sz="2250" b="0">
                 <a:solidFill>
                   <a:srgbClr val="182431"/>
@@ -8014,6 +8252,7 @@
               </a:defRPr>
             </a:lvl8pPr>
             <a:lvl9pPr>
+              <a:buNone/>
               <a:defRPr sz="2250" b="0">
                 <a:solidFill>
                   <a:srgbClr val="182431"/>
@@ -8026,6 +8265,7 @@
           </a:lstStyle>
           <a:p xmlns:a="http://schemas.openxmlformats.org/drawingml/2006/main">
             <a:pPr>
+              <a:buNone/>
               <a:defRPr sz="2250" b="0">
                 <a:solidFill>
                   <a:srgbClr val="182431"/>
@@ -8090,6 +8330,7 @@
               </a:defRPr>
             </a:defPPr>
             <a:lvl1pPr>
+              <a:buNone/>
               <a:defRPr sz="2250" b="0">
                 <a:solidFill>
                   <a:srgbClr val="182431"/>
@@ -8100,6 +8341,7 @@
               </a:defRPr>
             </a:lvl1pPr>
             <a:lvl2pPr>
+              <a:buNone/>
               <a:defRPr sz="2250" b="0">
                 <a:solidFill>
                   <a:srgbClr val="182431"/>
@@ -8110,6 +8352,7 @@
               </a:defRPr>
             </a:lvl2pPr>
             <a:lvl3pPr>
+              <a:buNone/>
               <a:defRPr sz="2250" b="0">
                 <a:solidFill>
                   <a:srgbClr val="182431"/>
@@ -8120,6 +8363,7 @@
               </a:defRPr>
             </a:lvl3pPr>
             <a:lvl4pPr>
+              <a:buNone/>
               <a:defRPr sz="2250" b="0">
                 <a:solidFill>
                   <a:srgbClr val="182431"/>
@@ -8130,6 +8374,7 @@
               </a:defRPr>
             </a:lvl4pPr>
             <a:lvl5pPr>
+              <a:buNone/>
               <a:defRPr sz="2250" b="0">
                 <a:solidFill>
                   <a:srgbClr val="182431"/>
@@ -8140,6 +8385,7 @@
               </a:defRPr>
             </a:lvl5pPr>
             <a:lvl6pPr>
+              <a:buNone/>
               <a:defRPr sz="2250" b="0">
                 <a:solidFill>
                   <a:srgbClr val="182431"/>
@@ -8150,6 +8396,7 @@
               </a:defRPr>
             </a:lvl6pPr>
             <a:lvl7pPr>
+              <a:buNone/>
               <a:defRPr sz="2250" b="0">
                 <a:solidFill>
                   <a:srgbClr val="182431"/>
@@ -8160,6 +8407,7 @@
               </a:defRPr>
             </a:lvl7pPr>
             <a:lvl8pPr>
+              <a:buNone/>
               <a:defRPr sz="2250" b="0">
                 <a:solidFill>
                   <a:srgbClr val="182431"/>
@@ -8170,6 +8418,7 @@
               </a:defRPr>
             </a:lvl8pPr>
             <a:lvl9pPr>
+              <a:buNone/>
               <a:defRPr sz="2250" b="0">
                 <a:solidFill>
                   <a:srgbClr val="182431"/>
@@ -8182,6 +8431,7 @@
           </a:lstStyle>
           <a:p xmlns:a="http://schemas.openxmlformats.org/drawingml/2006/main">
             <a:pPr>
+              <a:buNone/>
               <a:defRPr sz="2250" b="0">
                 <a:solidFill>
                   <a:srgbClr val="182431"/>
@@ -8246,6 +8496,7 @@
               </a:defRPr>
             </a:defPPr>
             <a:lvl1pPr>
+              <a:buNone/>
               <a:defRPr sz="2250" b="0">
                 <a:solidFill>
                   <a:srgbClr val="182431"/>
@@ -8256,6 +8507,7 @@
               </a:defRPr>
             </a:lvl1pPr>
             <a:lvl2pPr>
+              <a:buNone/>
               <a:defRPr sz="2250" b="0">
                 <a:solidFill>
                   <a:srgbClr val="182431"/>
@@ -8266,6 +8518,7 @@
               </a:defRPr>
             </a:lvl2pPr>
             <a:lvl3pPr>
+              <a:buNone/>
               <a:defRPr sz="2250" b="0">
                 <a:solidFill>
                   <a:srgbClr val="182431"/>
@@ -8276,6 +8529,7 @@
               </a:defRPr>
             </a:lvl3pPr>
             <a:lvl4pPr>
+              <a:buNone/>
               <a:defRPr sz="2250" b="0">
                 <a:solidFill>
                   <a:srgbClr val="182431"/>
@@ -8286,6 +8540,7 @@
               </a:defRPr>
             </a:lvl4pPr>
             <a:lvl5pPr>
+              <a:buNone/>
               <a:defRPr sz="2250" b="0">
                 <a:solidFill>
                   <a:srgbClr val="182431"/>
@@ -8296,6 +8551,7 @@
               </a:defRPr>
             </a:lvl5pPr>
             <a:lvl6pPr>
+              <a:buNone/>
               <a:defRPr sz="2250" b="0">
                 <a:solidFill>
                   <a:srgbClr val="182431"/>
@@ -8306,6 +8562,7 @@
               </a:defRPr>
             </a:lvl6pPr>
             <a:lvl7pPr>
+              <a:buNone/>
               <a:defRPr sz="2250" b="0">
                 <a:solidFill>
                   <a:srgbClr val="182431"/>
@@ -8316,6 +8573,7 @@
               </a:defRPr>
             </a:lvl7pPr>
             <a:lvl8pPr>
+              <a:buNone/>
               <a:defRPr sz="2250" b="0">
                 <a:solidFill>
                   <a:srgbClr val="182431"/>
@@ -8326,6 +8584,7 @@
               </a:defRPr>
             </a:lvl8pPr>
             <a:lvl9pPr>
+              <a:buNone/>
               <a:defRPr sz="2250" b="0">
                 <a:solidFill>
                   <a:srgbClr val="182431"/>
@@ -8338,6 +8597,7 @@
           </a:lstStyle>
           <a:p xmlns:a="http://schemas.openxmlformats.org/drawingml/2006/main">
             <a:pPr>
+              <a:buNone/>
               <a:defRPr sz="2250" b="0">
                 <a:solidFill>
                   <a:srgbClr val="182431"/>
@@ -8431,6 +8691,7 @@
               </a:defRPr>
             </a:defPPr>
             <a:lvl1pPr>
+              <a:buNone/>
               <a:defRPr sz="3300" b="1">
                 <a:solidFill>
                   <a:srgbClr val="182431"/>
@@ -8441,6 +8702,7 @@
               </a:defRPr>
             </a:lvl1pPr>
             <a:lvl2pPr>
+              <a:buNone/>
               <a:defRPr sz="3300" b="1">
                 <a:solidFill>
                   <a:srgbClr val="182431"/>
@@ -8451,6 +8713,7 @@
               </a:defRPr>
             </a:lvl2pPr>
             <a:lvl3pPr>
+              <a:buNone/>
               <a:defRPr sz="3300" b="1">
                 <a:solidFill>
                   <a:srgbClr val="182431"/>
@@ -8461,6 +8724,7 @@
               </a:defRPr>
             </a:lvl3pPr>
             <a:lvl4pPr>
+              <a:buNone/>
               <a:defRPr sz="3300" b="1">
                 <a:solidFill>
                   <a:srgbClr val="182431"/>
@@ -8471,6 +8735,7 @@
               </a:defRPr>
             </a:lvl4pPr>
             <a:lvl5pPr>
+              <a:buNone/>
               <a:defRPr sz="3300" b="1">
                 <a:solidFill>
                   <a:srgbClr val="182431"/>
@@ -8481,6 +8746,7 @@
               </a:defRPr>
             </a:lvl5pPr>
             <a:lvl6pPr>
+              <a:buNone/>
               <a:defRPr sz="3300" b="1">
                 <a:solidFill>
                   <a:srgbClr val="182431"/>
@@ -8491,6 +8757,7 @@
               </a:defRPr>
             </a:lvl6pPr>
             <a:lvl7pPr>
+              <a:buNone/>
               <a:defRPr sz="3300" b="1">
                 <a:solidFill>
                   <a:srgbClr val="182431"/>
@@ -8501,6 +8768,7 @@
               </a:defRPr>
             </a:lvl7pPr>
             <a:lvl8pPr>
+              <a:buNone/>
               <a:defRPr sz="3300" b="1">
                 <a:solidFill>
                   <a:srgbClr val="182431"/>
@@ -8511,6 +8779,7 @@
               </a:defRPr>
             </a:lvl8pPr>
             <a:lvl9pPr>
+              <a:buNone/>
               <a:defRPr sz="3300" b="1">
                 <a:solidFill>
                   <a:srgbClr val="182431"/>
@@ -8523,6 +8792,7 @@
           </a:lstStyle>
           <a:p xmlns:a="http://schemas.openxmlformats.org/drawingml/2006/main">
             <a:pPr>
+              <a:buNone/>
               <a:defRPr sz="3300" b="1">
                 <a:solidFill>
                   <a:srgbClr val="182431"/>
@@ -8587,6 +8857,7 @@
               </a:defRPr>
             </a:defPPr>
             <a:lvl1pPr>
+              <a:buNone/>
               <a:defRPr sz="2250" b="0">
                 <a:solidFill>
                   <a:srgbClr val="182431"/>
@@ -8597,6 +8868,7 @@
               </a:defRPr>
             </a:lvl1pPr>
             <a:lvl2pPr>
+              <a:buNone/>
               <a:defRPr sz="2250" b="0">
                 <a:solidFill>
                   <a:srgbClr val="182431"/>
@@ -8607,6 +8879,7 @@
               </a:defRPr>
             </a:lvl2pPr>
             <a:lvl3pPr>
+              <a:buNone/>
               <a:defRPr sz="2250" b="0">
                 <a:solidFill>
                   <a:srgbClr val="182431"/>
@@ -8617,6 +8890,7 @@
               </a:defRPr>
             </a:lvl3pPr>
             <a:lvl4pPr>
+              <a:buNone/>
               <a:defRPr sz="2250" b="0">
                 <a:solidFill>
                   <a:srgbClr val="182431"/>
@@ -8627,6 +8901,7 @@
               </a:defRPr>
             </a:lvl4pPr>
             <a:lvl5pPr>
+              <a:buNone/>
               <a:defRPr sz="2250" b="0">
                 <a:solidFill>
                   <a:srgbClr val="182431"/>
@@ -8637,6 +8912,7 @@
               </a:defRPr>
             </a:lvl5pPr>
             <a:lvl6pPr>
+              <a:buNone/>
               <a:defRPr sz="2250" b="0">
                 <a:solidFill>
                   <a:srgbClr val="182431"/>
@@ -8647,6 +8923,7 @@
               </a:defRPr>
             </a:lvl6pPr>
             <a:lvl7pPr>
+              <a:buNone/>
               <a:defRPr sz="2250" b="0">
                 <a:solidFill>
                   <a:srgbClr val="182431"/>
@@ -8657,6 +8934,7 @@
               </a:defRPr>
             </a:lvl7pPr>
             <a:lvl8pPr>
+              <a:buNone/>
               <a:defRPr sz="2250" b="0">
                 <a:solidFill>
                   <a:srgbClr val="182431"/>
@@ -8667,6 +8945,7 @@
               </a:defRPr>
             </a:lvl8pPr>
             <a:lvl9pPr>
+              <a:buNone/>
               <a:defRPr sz="2250" b="0">
                 <a:solidFill>
                   <a:srgbClr val="182431"/>
@@ -8679,6 +8958,7 @@
           </a:lstStyle>
           <a:p xmlns:a="http://schemas.openxmlformats.org/drawingml/2006/main">
             <a:pPr>
+              <a:buNone/>
               <a:defRPr sz="2250" b="0">
                 <a:solidFill>
                   <a:srgbClr val="182431"/>
@@ -8743,6 +9023,7 @@
               </a:defRPr>
             </a:defPPr>
             <a:lvl1pPr>
+              <a:buNone/>
               <a:defRPr sz="2250" b="0">
                 <a:solidFill>
                   <a:srgbClr val="182431"/>
@@ -8753,6 +9034,7 @@
               </a:defRPr>
             </a:lvl1pPr>
             <a:lvl2pPr>
+              <a:buNone/>
               <a:defRPr sz="2250" b="0">
                 <a:solidFill>
                   <a:srgbClr val="182431"/>
@@ -8763,6 +9045,7 @@
               </a:defRPr>
             </a:lvl2pPr>
             <a:lvl3pPr>
+              <a:buNone/>
               <a:defRPr sz="2250" b="0">
                 <a:solidFill>
                   <a:srgbClr val="182431"/>
@@ -8773,6 +9056,7 @@
               </a:defRPr>
             </a:lvl3pPr>
             <a:lvl4pPr>
+              <a:buNone/>
               <a:defRPr sz="2250" b="0">
                 <a:solidFill>
                   <a:srgbClr val="182431"/>
@@ -8783,6 +9067,7 @@
               </a:defRPr>
             </a:lvl4pPr>
             <a:lvl5pPr>
+              <a:buNone/>
               <a:defRPr sz="2250" b="0">
                 <a:solidFill>
                   <a:srgbClr val="182431"/>
@@ -8793,6 +9078,7 @@
               </a:defRPr>
             </a:lvl5pPr>
             <a:lvl6pPr>
+              <a:buNone/>
               <a:defRPr sz="2250" b="0">
                 <a:solidFill>
                   <a:srgbClr val="182431"/>
@@ -8803,6 +9089,7 @@
               </a:defRPr>
             </a:lvl6pPr>
             <a:lvl7pPr>
+              <a:buNone/>
               <a:defRPr sz="2250" b="0">
                 <a:solidFill>
                   <a:srgbClr val="182431"/>
@@ -8813,6 +9100,7 @@
               </a:defRPr>
             </a:lvl7pPr>
             <a:lvl8pPr>
+              <a:buNone/>
               <a:defRPr sz="2250" b="0">
                 <a:solidFill>
                   <a:srgbClr val="182431"/>
@@ -8823,6 +9111,7 @@
               </a:defRPr>
             </a:lvl8pPr>
             <a:lvl9pPr>
+              <a:buNone/>
               <a:defRPr sz="2250" b="0">
                 <a:solidFill>
                   <a:srgbClr val="182431"/>
@@ -8835,6 +9124,7 @@
           </a:lstStyle>
           <a:p xmlns:a="http://schemas.openxmlformats.org/drawingml/2006/main">
             <a:pPr>
+              <a:buNone/>
               <a:defRPr sz="2250" b="0">
                 <a:solidFill>
                   <a:srgbClr val="182431"/>
@@ -8899,6 +9189,7 @@
               </a:defRPr>
             </a:defPPr>
             <a:lvl1pPr>
+              <a:buNone/>
               <a:defRPr sz="2250" b="0">
                 <a:solidFill>
                   <a:srgbClr val="182431"/>
@@ -8909,6 +9200,7 @@
               </a:defRPr>
             </a:lvl1pPr>
             <a:lvl2pPr>
+              <a:buNone/>
               <a:defRPr sz="2250" b="0">
                 <a:solidFill>
                   <a:srgbClr val="182431"/>
@@ -8919,6 +9211,7 @@
               </a:defRPr>
             </a:lvl2pPr>
             <a:lvl3pPr>
+              <a:buNone/>
               <a:defRPr sz="2250" b="0">
                 <a:solidFill>
                   <a:srgbClr val="182431"/>
@@ -8929,6 +9222,7 @@
               </a:defRPr>
             </a:lvl3pPr>
             <a:lvl4pPr>
+              <a:buNone/>
               <a:defRPr sz="2250" b="0">
                 <a:solidFill>
                   <a:srgbClr val="182431"/>
@@ -8939,6 +9233,7 @@
               </a:defRPr>
             </a:lvl4pPr>
             <a:lvl5pPr>
+              <a:buNone/>
               <a:defRPr sz="2250" b="0">
                 <a:solidFill>
                   <a:srgbClr val="182431"/>
@@ -8949,6 +9244,7 @@
               </a:defRPr>
             </a:lvl5pPr>
             <a:lvl6pPr>
+              <a:buNone/>
               <a:defRPr sz="2250" b="0">
                 <a:solidFill>
                   <a:srgbClr val="182431"/>
@@ -8959,6 +9255,7 @@
               </a:defRPr>
             </a:lvl6pPr>
             <a:lvl7pPr>
+              <a:buNone/>
               <a:defRPr sz="2250" b="0">
                 <a:solidFill>
                   <a:srgbClr val="182431"/>
@@ -8969,6 +9266,7 @@
               </a:defRPr>
             </a:lvl7pPr>
             <a:lvl8pPr>
+              <a:buNone/>
               <a:defRPr sz="2250" b="0">
                 <a:solidFill>
                   <a:srgbClr val="182431"/>
@@ -8979,6 +9277,7 @@
               </a:defRPr>
             </a:lvl8pPr>
             <a:lvl9pPr>
+              <a:buNone/>
               <a:defRPr sz="2250" b="0">
                 <a:solidFill>
                   <a:srgbClr val="182431"/>
@@ -8991,6 +9290,7 @@
           </a:lstStyle>
           <a:p xmlns:a="http://schemas.openxmlformats.org/drawingml/2006/main">
             <a:pPr>
+              <a:buNone/>
               <a:defRPr sz="2250" b="0">
                 <a:solidFill>
                   <a:srgbClr val="182431"/>
@@ -9055,6 +9355,7 @@
               </a:defRPr>
             </a:defPPr>
             <a:lvl1pPr>
+              <a:buNone/>
               <a:defRPr sz="2250" b="0">
                 <a:solidFill>
                   <a:srgbClr val="182431"/>
@@ -9065,6 +9366,7 @@
               </a:defRPr>
             </a:lvl1pPr>
             <a:lvl2pPr>
+              <a:buNone/>
               <a:defRPr sz="2250" b="0">
                 <a:solidFill>
                   <a:srgbClr val="182431"/>
@@ -9075,6 +9377,7 @@
               </a:defRPr>
             </a:lvl2pPr>
             <a:lvl3pPr>
+              <a:buNone/>
               <a:defRPr sz="2250" b="0">
                 <a:solidFill>
                   <a:srgbClr val="182431"/>
@@ -9085,6 +9388,7 @@
               </a:defRPr>
             </a:lvl3pPr>
             <a:lvl4pPr>
+              <a:buNone/>
               <a:defRPr sz="2250" b="0">
                 <a:solidFill>
                   <a:srgbClr val="182431"/>
@@ -9095,6 +9399,7 @@
               </a:defRPr>
             </a:lvl4pPr>
             <a:lvl5pPr>
+              <a:buNone/>
               <a:defRPr sz="2250" b="0">
                 <a:solidFill>
                   <a:srgbClr val="182431"/>
@@ -9105,6 +9410,7 @@
               </a:defRPr>
             </a:lvl5pPr>
             <a:lvl6pPr>
+              <a:buNone/>
               <a:defRPr sz="2250" b="0">
                 <a:solidFill>
                   <a:srgbClr val="182431"/>
@@ -9115,6 +9421,7 @@
               </a:defRPr>
             </a:lvl6pPr>
             <a:lvl7pPr>
+              <a:buNone/>
               <a:defRPr sz="2250" b="0">
                 <a:solidFill>
                   <a:srgbClr val="182431"/>
@@ -9125,6 +9432,7 @@
               </a:defRPr>
             </a:lvl7pPr>
             <a:lvl8pPr>
+              <a:buNone/>
               <a:defRPr sz="2250" b="0">
                 <a:solidFill>
                   <a:srgbClr val="182431"/>
@@ -9135,6 +9443,7 @@
               </a:defRPr>
             </a:lvl8pPr>
             <a:lvl9pPr>
+              <a:buNone/>
               <a:defRPr sz="2250" b="0">
                 <a:solidFill>
                   <a:srgbClr val="182431"/>
@@ -9147,6 +9456,7 @@
           </a:lstStyle>
           <a:p xmlns:a="http://schemas.openxmlformats.org/drawingml/2006/main">
             <a:pPr>
+              <a:buNone/>
               <a:defRPr sz="2250" b="0">
                 <a:solidFill>
                   <a:srgbClr val="182431"/>
@@ -9165,7 +9475,7 @@
                 <a:ea typeface="Arial"/>
                 <a:cs typeface="Arial"/>
               </a:rPr>
-              <a:t>M10 records the user’s earlier manual verification.</a:t>
+              <a:t>M10 records manual verification of editor cleanup.</a:t>
             </a:r>
           </a:p>
         </p:txBody>
@@ -9240,6 +9550,7 @@
               </a:defRPr>
             </a:defPPr>
             <a:lvl1pPr>
+              <a:buNone/>
               <a:defRPr sz="3300" b="1">
                 <a:solidFill>
                   <a:srgbClr val="182431"/>
@@ -9250,6 +9561,7 @@
               </a:defRPr>
             </a:lvl1pPr>
             <a:lvl2pPr>
+              <a:buNone/>
               <a:defRPr sz="3300" b="1">
                 <a:solidFill>
                   <a:srgbClr val="182431"/>
@@ -9260,6 +9572,7 @@
               </a:defRPr>
             </a:lvl2pPr>
             <a:lvl3pPr>
+              <a:buNone/>
               <a:defRPr sz="3300" b="1">
                 <a:solidFill>
                   <a:srgbClr val="182431"/>
@@ -9270,6 +9583,7 @@
               </a:defRPr>
             </a:lvl3pPr>
             <a:lvl4pPr>
+              <a:buNone/>
               <a:defRPr sz="3300" b="1">
                 <a:solidFill>
                   <a:srgbClr val="182431"/>
@@ -9280,6 +9594,7 @@
               </a:defRPr>
             </a:lvl4pPr>
             <a:lvl5pPr>
+              <a:buNone/>
               <a:defRPr sz="3300" b="1">
                 <a:solidFill>
                   <a:srgbClr val="182431"/>
@@ -9290,6 +9605,7 @@
               </a:defRPr>
             </a:lvl5pPr>
             <a:lvl6pPr>
+              <a:buNone/>
               <a:defRPr sz="3300" b="1">
                 <a:solidFill>
                   <a:srgbClr val="182431"/>
@@ -9300,6 +9616,7 @@
               </a:defRPr>
             </a:lvl6pPr>
             <a:lvl7pPr>
+              <a:buNone/>
               <a:defRPr sz="3300" b="1">
                 <a:solidFill>
                   <a:srgbClr val="182431"/>
@@ -9310,6 +9627,7 @@
               </a:defRPr>
             </a:lvl7pPr>
             <a:lvl8pPr>
+              <a:buNone/>
               <a:defRPr sz="3300" b="1">
                 <a:solidFill>
                   <a:srgbClr val="182431"/>
@@ -9320,6 +9638,7 @@
               </a:defRPr>
             </a:lvl8pPr>
             <a:lvl9pPr>
+              <a:buNone/>
               <a:defRPr sz="3300" b="1">
                 <a:solidFill>
                   <a:srgbClr val="182431"/>
@@ -9332,6 +9651,7 @@
           </a:lstStyle>
           <a:p xmlns:a="http://schemas.openxmlformats.org/drawingml/2006/main">
             <a:pPr>
+              <a:buNone/>
               <a:defRPr sz="3300" b="1">
                 <a:solidFill>
                   <a:srgbClr val="182431"/>
@@ -9396,6 +9716,7 @@
               </a:defRPr>
             </a:defPPr>
             <a:lvl1pPr>
+              <a:buNone/>
               <a:defRPr sz="2250" b="0">
                 <a:solidFill>
                   <a:srgbClr val="182431"/>
@@ -9406,6 +9727,7 @@
               </a:defRPr>
             </a:lvl1pPr>
             <a:lvl2pPr>
+              <a:buNone/>
               <a:defRPr sz="2250" b="0">
                 <a:solidFill>
                   <a:srgbClr val="182431"/>
@@ -9416,6 +9738,7 @@
               </a:defRPr>
             </a:lvl2pPr>
             <a:lvl3pPr>
+              <a:buNone/>
               <a:defRPr sz="2250" b="0">
                 <a:solidFill>
                   <a:srgbClr val="182431"/>
@@ -9426,6 +9749,7 @@
               </a:defRPr>
             </a:lvl3pPr>
             <a:lvl4pPr>
+              <a:buNone/>
               <a:defRPr sz="2250" b="0">
                 <a:solidFill>
                   <a:srgbClr val="182431"/>
@@ -9436,6 +9760,7 @@
               </a:defRPr>
             </a:lvl4pPr>
             <a:lvl5pPr>
+              <a:buNone/>
               <a:defRPr sz="2250" b="0">
                 <a:solidFill>
                   <a:srgbClr val="182431"/>
@@ -9446,6 +9771,7 @@
               </a:defRPr>
             </a:lvl5pPr>
             <a:lvl6pPr>
+              <a:buNone/>
               <a:defRPr sz="2250" b="0">
                 <a:solidFill>
                   <a:srgbClr val="182431"/>
@@ -9456,6 +9782,7 @@
               </a:defRPr>
             </a:lvl6pPr>
             <a:lvl7pPr>
+              <a:buNone/>
               <a:defRPr sz="2250" b="0">
                 <a:solidFill>
                   <a:srgbClr val="182431"/>
@@ -9466,6 +9793,7 @@
               </a:defRPr>
             </a:lvl7pPr>
             <a:lvl8pPr>
+              <a:buNone/>
               <a:defRPr sz="2250" b="0">
                 <a:solidFill>
                   <a:srgbClr val="182431"/>
@@ -9476,6 +9804,7 @@
               </a:defRPr>
             </a:lvl8pPr>
             <a:lvl9pPr>
+              <a:buNone/>
               <a:defRPr sz="2250" b="0">
                 <a:solidFill>
                   <a:srgbClr val="182431"/>
@@ -9488,6 +9817,7 @@
           </a:lstStyle>
           <a:p xmlns:a="http://schemas.openxmlformats.org/drawingml/2006/main">
             <a:pPr>
+              <a:buNone/>
               <a:defRPr sz="2250" b="0">
                 <a:solidFill>
                   <a:srgbClr val="182431"/>
@@ -9552,6 +9882,7 @@
               </a:defRPr>
             </a:defPPr>
             <a:lvl1pPr>
+              <a:buNone/>
               <a:defRPr sz="2250" b="0">
                 <a:solidFill>
                   <a:srgbClr val="182431"/>
@@ -9562,6 +9893,7 @@
               </a:defRPr>
             </a:lvl1pPr>
             <a:lvl2pPr>
+              <a:buNone/>
               <a:defRPr sz="2250" b="0">
                 <a:solidFill>
                   <a:srgbClr val="182431"/>
@@ -9572,6 +9904,7 @@
               </a:defRPr>
             </a:lvl2pPr>
             <a:lvl3pPr>
+              <a:buNone/>
               <a:defRPr sz="2250" b="0">
                 <a:solidFill>
                   <a:srgbClr val="182431"/>
@@ -9582,6 +9915,7 @@
               </a:defRPr>
             </a:lvl3pPr>
             <a:lvl4pPr>
+              <a:buNone/>
               <a:defRPr sz="2250" b="0">
                 <a:solidFill>
                   <a:srgbClr val="182431"/>
@@ -9592,6 +9926,7 @@
               </a:defRPr>
             </a:lvl4pPr>
             <a:lvl5pPr>
+              <a:buNone/>
               <a:defRPr sz="2250" b="0">
                 <a:solidFill>
                   <a:srgbClr val="182431"/>
@@ -9602,6 +9937,7 @@
               </a:defRPr>
             </a:lvl5pPr>
             <a:lvl6pPr>
+              <a:buNone/>
               <a:defRPr sz="2250" b="0">
                 <a:solidFill>
                   <a:srgbClr val="182431"/>
@@ -9612,6 +9948,7 @@
               </a:defRPr>
             </a:lvl6pPr>
             <a:lvl7pPr>
+              <a:buNone/>
               <a:defRPr sz="2250" b="0">
                 <a:solidFill>
                   <a:srgbClr val="182431"/>
@@ -9622,6 +9959,7 @@
               </a:defRPr>
             </a:lvl7pPr>
             <a:lvl8pPr>
+              <a:buNone/>
               <a:defRPr sz="2250" b="0">
                 <a:solidFill>
                   <a:srgbClr val="182431"/>
@@ -9632,6 +9970,7 @@
               </a:defRPr>
             </a:lvl8pPr>
             <a:lvl9pPr>
+              <a:buNone/>
               <a:defRPr sz="2250" b="0">
                 <a:solidFill>
                   <a:srgbClr val="182431"/>
@@ -9644,6 +9983,7 @@
           </a:lstStyle>
           <a:p xmlns:a="http://schemas.openxmlformats.org/drawingml/2006/main">
             <a:pPr>
+              <a:buNone/>
               <a:defRPr sz="2250" b="0">
                 <a:solidFill>
                   <a:srgbClr val="182431"/>
@@ -9708,6 +10048,7 @@
               </a:defRPr>
             </a:defPPr>
             <a:lvl1pPr>
+              <a:buNone/>
               <a:defRPr sz="2250" b="0">
                 <a:solidFill>
                   <a:srgbClr val="182431"/>
@@ -9718,6 +10059,7 @@
               </a:defRPr>
             </a:lvl1pPr>
             <a:lvl2pPr>
+              <a:buNone/>
               <a:defRPr sz="2250" b="0">
                 <a:solidFill>
                   <a:srgbClr val="182431"/>
@@ -9728,6 +10070,7 @@
               </a:defRPr>
             </a:lvl2pPr>
             <a:lvl3pPr>
+              <a:buNone/>
               <a:defRPr sz="2250" b="0">
                 <a:solidFill>
                   <a:srgbClr val="182431"/>
@@ -9738,6 +10081,7 @@
               </a:defRPr>
             </a:lvl3pPr>
             <a:lvl4pPr>
+              <a:buNone/>
               <a:defRPr sz="2250" b="0">
                 <a:solidFill>
                   <a:srgbClr val="182431"/>
@@ -9748,6 +10092,7 @@
               </a:defRPr>
             </a:lvl4pPr>
             <a:lvl5pPr>
+              <a:buNone/>
               <a:defRPr sz="2250" b="0">
                 <a:solidFill>
                   <a:srgbClr val="182431"/>
@@ -9758,6 +10103,7 @@
               </a:defRPr>
             </a:lvl5pPr>
             <a:lvl6pPr>
+              <a:buNone/>
               <a:defRPr sz="2250" b="0">
                 <a:solidFill>
                   <a:srgbClr val="182431"/>
@@ -9768,6 +10114,7 @@
               </a:defRPr>
             </a:lvl6pPr>
             <a:lvl7pPr>
+              <a:buNone/>
               <a:defRPr sz="2250" b="0">
                 <a:solidFill>
                   <a:srgbClr val="182431"/>
@@ -9778,6 +10125,7 @@
               </a:defRPr>
             </a:lvl7pPr>
             <a:lvl8pPr>
+              <a:buNone/>
               <a:defRPr sz="2250" b="0">
                 <a:solidFill>
                   <a:srgbClr val="182431"/>
@@ -9788,6 +10136,7 @@
               </a:defRPr>
             </a:lvl8pPr>
             <a:lvl9pPr>
+              <a:buNone/>
               <a:defRPr sz="2250" b="0">
                 <a:solidFill>
                   <a:srgbClr val="182431"/>
@@ -9800,6 +10149,7 @@
           </a:lstStyle>
           <a:p xmlns:a="http://schemas.openxmlformats.org/drawingml/2006/main">
             <a:pPr>
+              <a:buNone/>
               <a:defRPr sz="2250" b="0">
                 <a:solidFill>
                   <a:srgbClr val="182431"/>
@@ -9864,6 +10214,7 @@
               </a:defRPr>
             </a:defPPr>
             <a:lvl1pPr>
+              <a:buNone/>
               <a:defRPr sz="2250" b="0">
                 <a:solidFill>
                   <a:srgbClr val="182431"/>
@@ -9874,6 +10225,7 @@
               </a:defRPr>
             </a:lvl1pPr>
             <a:lvl2pPr>
+              <a:buNone/>
               <a:defRPr sz="2250" b="0">
                 <a:solidFill>
                   <a:srgbClr val="182431"/>
@@ -9884,6 +10236,7 @@
               </a:defRPr>
             </a:lvl2pPr>
             <a:lvl3pPr>
+              <a:buNone/>
               <a:defRPr sz="2250" b="0">
                 <a:solidFill>
                   <a:srgbClr val="182431"/>
@@ -9894,6 +10247,7 @@
               </a:defRPr>
             </a:lvl3pPr>
             <a:lvl4pPr>
+              <a:buNone/>
               <a:defRPr sz="2250" b="0">
                 <a:solidFill>
                   <a:srgbClr val="182431"/>
@@ -9904,6 +10258,7 @@
               </a:defRPr>
             </a:lvl4pPr>
             <a:lvl5pPr>
+              <a:buNone/>
               <a:defRPr sz="2250" b="0">
                 <a:solidFill>
                   <a:srgbClr val="182431"/>
@@ -9914,6 +10269,7 @@
               </a:defRPr>
             </a:lvl5pPr>
             <a:lvl6pPr>
+              <a:buNone/>
               <a:defRPr sz="2250" b="0">
                 <a:solidFill>
                   <a:srgbClr val="182431"/>
@@ -9924,6 +10280,7 @@
               </a:defRPr>
             </a:lvl6pPr>
             <a:lvl7pPr>
+              <a:buNone/>
               <a:defRPr sz="2250" b="0">
                 <a:solidFill>
                   <a:srgbClr val="182431"/>
@@ -9934,6 +10291,7 @@
               </a:defRPr>
             </a:lvl7pPr>
             <a:lvl8pPr>
+              <a:buNone/>
               <a:defRPr sz="2250" b="0">
                 <a:solidFill>
                   <a:srgbClr val="182431"/>
@@ -9944,6 +10302,7 @@
               </a:defRPr>
             </a:lvl8pPr>
             <a:lvl9pPr>
+              <a:buNone/>
               <a:defRPr sz="2250" b="0">
                 <a:solidFill>
                   <a:srgbClr val="182431"/>
@@ -9956,6 +10315,7 @@
           </a:lstStyle>
           <a:p xmlns:a="http://schemas.openxmlformats.org/drawingml/2006/main">
             <a:pPr>
+              <a:buNone/>
               <a:defRPr sz="2250" b="0">
                 <a:solidFill>
                   <a:srgbClr val="182431"/>
@@ -10049,6 +10409,7 @@
               </a:defRPr>
             </a:defPPr>
             <a:lvl1pPr>
+              <a:buNone/>
               <a:defRPr sz="3300" b="1">
                 <a:solidFill>
                   <a:srgbClr val="182431"/>
@@ -10059,6 +10420,7 @@
               </a:defRPr>
             </a:lvl1pPr>
             <a:lvl2pPr>
+              <a:buNone/>
               <a:defRPr sz="3300" b="1">
                 <a:solidFill>
                   <a:srgbClr val="182431"/>
@@ -10069,6 +10431,7 @@
               </a:defRPr>
             </a:lvl2pPr>
             <a:lvl3pPr>
+              <a:buNone/>
               <a:defRPr sz="3300" b="1">
                 <a:solidFill>
                   <a:srgbClr val="182431"/>
@@ -10079,6 +10442,7 @@
               </a:defRPr>
             </a:lvl3pPr>
             <a:lvl4pPr>
+              <a:buNone/>
               <a:defRPr sz="3300" b="1">
                 <a:solidFill>
                   <a:srgbClr val="182431"/>
@@ -10089,6 +10453,7 @@
               </a:defRPr>
             </a:lvl4pPr>
             <a:lvl5pPr>
+              <a:buNone/>
               <a:defRPr sz="3300" b="1">
                 <a:solidFill>
                   <a:srgbClr val="182431"/>
@@ -10099,6 +10464,7 @@
               </a:defRPr>
             </a:lvl5pPr>
             <a:lvl6pPr>
+              <a:buNone/>
               <a:defRPr sz="3300" b="1">
                 <a:solidFill>
                   <a:srgbClr val="182431"/>
@@ -10109,6 +10475,7 @@
               </a:defRPr>
             </a:lvl6pPr>
             <a:lvl7pPr>
+              <a:buNone/>
               <a:defRPr sz="3300" b="1">
                 <a:solidFill>
                   <a:srgbClr val="182431"/>
@@ -10119,6 +10486,7 @@
               </a:defRPr>
             </a:lvl7pPr>
             <a:lvl8pPr>
+              <a:buNone/>
               <a:defRPr sz="3300" b="1">
                 <a:solidFill>
                   <a:srgbClr val="182431"/>
@@ -10129,6 +10497,7 @@
               </a:defRPr>
             </a:lvl8pPr>
             <a:lvl9pPr>
+              <a:buNone/>
               <a:defRPr sz="3300" b="1">
                 <a:solidFill>
                   <a:srgbClr val="182431"/>
@@ -10141,6 +10510,7 @@
           </a:lstStyle>
           <a:p xmlns:a="http://schemas.openxmlformats.org/drawingml/2006/main">
             <a:pPr>
+              <a:buNone/>
               <a:defRPr sz="3300" b="1">
                 <a:solidFill>
                   <a:srgbClr val="182431"/>
@@ -10159,7 +10529,7 @@
                 <a:ea typeface="Arial"/>
                 <a:cs typeface="Arial"/>
               </a:rPr>
-              <a:t>Contribution accountability</a:t>
+              <a:t>Team contributions</a:t>
             </a:r>
           </a:p>
         </p:txBody>
@@ -10205,6 +10575,7 @@
               </a:defRPr>
             </a:defPPr>
             <a:lvl1pPr>
+              <a:buNone/>
               <a:defRPr sz="2250" b="0">
                 <a:solidFill>
                   <a:srgbClr val="182431"/>
@@ -10215,6 +10586,7 @@
               </a:defRPr>
             </a:lvl1pPr>
             <a:lvl2pPr>
+              <a:buNone/>
               <a:defRPr sz="2250" b="0">
                 <a:solidFill>
                   <a:srgbClr val="182431"/>
@@ -10225,6 +10597,7 @@
               </a:defRPr>
             </a:lvl2pPr>
             <a:lvl3pPr>
+              <a:buNone/>
               <a:defRPr sz="2250" b="0">
                 <a:solidFill>
                   <a:srgbClr val="182431"/>
@@ -10235,6 +10608,7 @@
               </a:defRPr>
             </a:lvl3pPr>
             <a:lvl4pPr>
+              <a:buNone/>
               <a:defRPr sz="2250" b="0">
                 <a:solidFill>
                   <a:srgbClr val="182431"/>
@@ -10245,6 +10619,7 @@
               </a:defRPr>
             </a:lvl4pPr>
             <a:lvl5pPr>
+              <a:buNone/>
               <a:defRPr sz="2250" b="0">
                 <a:solidFill>
                   <a:srgbClr val="182431"/>
@@ -10255,6 +10630,7 @@
               </a:defRPr>
             </a:lvl5pPr>
             <a:lvl6pPr>
+              <a:buNone/>
               <a:defRPr sz="2250" b="0">
                 <a:solidFill>
                   <a:srgbClr val="182431"/>
@@ -10265,6 +10641,7 @@
               </a:defRPr>
             </a:lvl6pPr>
             <a:lvl7pPr>
+              <a:buNone/>
               <a:defRPr sz="2250" b="0">
                 <a:solidFill>
                   <a:srgbClr val="182431"/>
@@ -10275,6 +10652,7 @@
               </a:defRPr>
             </a:lvl7pPr>
             <a:lvl8pPr>
+              <a:buNone/>
               <a:defRPr sz="2250" b="0">
                 <a:solidFill>
                   <a:srgbClr val="182431"/>
@@ -10285,6 +10663,7 @@
               </a:defRPr>
             </a:lvl8pPr>
             <a:lvl9pPr>
+              <a:buNone/>
               <a:defRPr sz="2250" b="0">
                 <a:solidFill>
                   <a:srgbClr val="182431"/>
@@ -10297,6 +10676,7 @@
           </a:lstStyle>
           <a:p xmlns:a="http://schemas.openxmlformats.org/drawingml/2006/main">
             <a:pPr>
+              <a:buNone/>
               <a:defRPr sz="2250" b="0">
                 <a:solidFill>
                   <a:srgbClr val="182431"/>
@@ -10361,6 +10741,7 @@
               </a:defRPr>
             </a:defPPr>
             <a:lvl1pPr>
+              <a:buNone/>
               <a:defRPr sz="2250" b="0">
                 <a:solidFill>
                   <a:srgbClr val="182431"/>
@@ -10371,6 +10752,7 @@
               </a:defRPr>
             </a:lvl1pPr>
             <a:lvl2pPr>
+              <a:buNone/>
               <a:defRPr sz="2250" b="0">
                 <a:solidFill>
                   <a:srgbClr val="182431"/>
@@ -10381,6 +10763,7 @@
               </a:defRPr>
             </a:lvl2pPr>
             <a:lvl3pPr>
+              <a:buNone/>
               <a:defRPr sz="2250" b="0">
                 <a:solidFill>
                   <a:srgbClr val="182431"/>
@@ -10391,6 +10774,7 @@
               </a:defRPr>
             </a:lvl3pPr>
             <a:lvl4pPr>
+              <a:buNone/>
               <a:defRPr sz="2250" b="0">
                 <a:solidFill>
                   <a:srgbClr val="182431"/>
@@ -10401,6 +10785,7 @@
               </a:defRPr>
             </a:lvl4pPr>
             <a:lvl5pPr>
+              <a:buNone/>
               <a:defRPr sz="2250" b="0">
                 <a:solidFill>
                   <a:srgbClr val="182431"/>
@@ -10411,6 +10796,7 @@
               </a:defRPr>
             </a:lvl5pPr>
             <a:lvl6pPr>
+              <a:buNone/>
               <a:defRPr sz="2250" b="0">
                 <a:solidFill>
                   <a:srgbClr val="182431"/>
@@ -10421,6 +10807,7 @@
               </a:defRPr>
             </a:lvl6pPr>
             <a:lvl7pPr>
+              <a:buNone/>
               <a:defRPr sz="2250" b="0">
                 <a:solidFill>
                   <a:srgbClr val="182431"/>
@@ -10431,6 +10818,7 @@
               </a:defRPr>
             </a:lvl7pPr>
             <a:lvl8pPr>
+              <a:buNone/>
               <a:defRPr sz="2250" b="0">
                 <a:solidFill>
                   <a:srgbClr val="182431"/>
@@ -10441,6 +10829,7 @@
               </a:defRPr>
             </a:lvl8pPr>
             <a:lvl9pPr>
+              <a:buNone/>
               <a:defRPr sz="2250" b="0">
                 <a:solidFill>
                   <a:srgbClr val="182431"/>
@@ -10453,6 +10842,7 @@
           </a:lstStyle>
           <a:p xmlns:a="http://schemas.openxmlformats.org/drawingml/2006/main">
             <a:pPr>
+              <a:buNone/>
               <a:defRPr sz="2250" b="0">
                 <a:solidFill>
                   <a:srgbClr val="182431"/>
@@ -10517,6 +10907,7 @@
               </a:defRPr>
             </a:defPPr>
             <a:lvl1pPr>
+              <a:buNone/>
               <a:defRPr sz="2250" b="0">
                 <a:solidFill>
                   <a:srgbClr val="182431"/>
@@ -10527,6 +10918,7 @@
               </a:defRPr>
             </a:lvl1pPr>
             <a:lvl2pPr>
+              <a:buNone/>
               <a:defRPr sz="2250" b="0">
                 <a:solidFill>
                   <a:srgbClr val="182431"/>
@@ -10537,6 +10929,7 @@
               </a:defRPr>
             </a:lvl2pPr>
             <a:lvl3pPr>
+              <a:buNone/>
               <a:defRPr sz="2250" b="0">
                 <a:solidFill>
                   <a:srgbClr val="182431"/>
@@ -10547,6 +10940,7 @@
               </a:defRPr>
             </a:lvl3pPr>
             <a:lvl4pPr>
+              <a:buNone/>
               <a:defRPr sz="2250" b="0">
                 <a:solidFill>
                   <a:srgbClr val="182431"/>
@@ -10557,6 +10951,7 @@
               </a:defRPr>
             </a:lvl4pPr>
             <a:lvl5pPr>
+              <a:buNone/>
               <a:defRPr sz="2250" b="0">
                 <a:solidFill>
                   <a:srgbClr val="182431"/>
@@ -10567,6 +10962,7 @@
               </a:defRPr>
             </a:lvl5pPr>
             <a:lvl6pPr>
+              <a:buNone/>
               <a:defRPr sz="2250" b="0">
                 <a:solidFill>
                   <a:srgbClr val="182431"/>
@@ -10577,6 +10973,7 @@
               </a:defRPr>
             </a:lvl6pPr>
             <a:lvl7pPr>
+              <a:buNone/>
               <a:defRPr sz="2250" b="0">
                 <a:solidFill>
                   <a:srgbClr val="182431"/>
@@ -10587,6 +10984,7 @@
               </a:defRPr>
             </a:lvl7pPr>
             <a:lvl8pPr>
+              <a:buNone/>
               <a:defRPr sz="2250" b="0">
                 <a:solidFill>
                   <a:srgbClr val="182431"/>
@@ -10597,6 +10995,7 @@
               </a:defRPr>
             </a:lvl8pPr>
             <a:lvl9pPr>
+              <a:buNone/>
               <a:defRPr sz="2250" b="0">
                 <a:solidFill>
                   <a:srgbClr val="182431"/>
@@ -10609,6 +11008,7 @@
           </a:lstStyle>
           <a:p xmlns:a="http://schemas.openxmlformats.org/drawingml/2006/main">
             <a:pPr>
+              <a:buNone/>
               <a:defRPr sz="2250" b="0">
                 <a:solidFill>
                   <a:srgbClr val="182431"/>
@@ -10673,6 +11073,7 @@
               </a:defRPr>
             </a:defPPr>
             <a:lvl1pPr>
+              <a:buNone/>
               <a:defRPr sz="2250" b="0">
                 <a:solidFill>
                   <a:srgbClr val="182431"/>
@@ -10683,6 +11084,7 @@
               </a:defRPr>
             </a:lvl1pPr>
             <a:lvl2pPr>
+              <a:buNone/>
               <a:defRPr sz="2250" b="0">
                 <a:solidFill>
                   <a:srgbClr val="182431"/>
@@ -10693,6 +11095,7 @@
               </a:defRPr>
             </a:lvl2pPr>
             <a:lvl3pPr>
+              <a:buNone/>
               <a:defRPr sz="2250" b="0">
                 <a:solidFill>
                   <a:srgbClr val="182431"/>
@@ -10703,6 +11106,7 @@
               </a:defRPr>
             </a:lvl3pPr>
             <a:lvl4pPr>
+              <a:buNone/>
               <a:defRPr sz="2250" b="0">
                 <a:solidFill>
                   <a:srgbClr val="182431"/>
@@ -10713,6 +11117,7 @@
               </a:defRPr>
             </a:lvl4pPr>
             <a:lvl5pPr>
+              <a:buNone/>
               <a:defRPr sz="2250" b="0">
                 <a:solidFill>
                   <a:srgbClr val="182431"/>
@@ -10723,6 +11128,7 @@
               </a:defRPr>
             </a:lvl5pPr>
             <a:lvl6pPr>
+              <a:buNone/>
               <a:defRPr sz="2250" b="0">
                 <a:solidFill>
                   <a:srgbClr val="182431"/>
@@ -10733,6 +11139,7 @@
               </a:defRPr>
             </a:lvl6pPr>
             <a:lvl7pPr>
+              <a:buNone/>
               <a:defRPr sz="2250" b="0">
                 <a:solidFill>
                   <a:srgbClr val="182431"/>
@@ -10743,6 +11150,7 @@
               </a:defRPr>
             </a:lvl7pPr>
             <a:lvl8pPr>
+              <a:buNone/>
               <a:defRPr sz="2250" b="0">
                 <a:solidFill>
                   <a:srgbClr val="182431"/>
@@ -10753,6 +11161,7 @@
               </a:defRPr>
             </a:lvl8pPr>
             <a:lvl9pPr>
+              <a:buNone/>
               <a:defRPr sz="2250" b="0">
                 <a:solidFill>
                   <a:srgbClr val="182431"/>
@@ -10765,6 +11174,7 @@
           </a:lstStyle>
           <a:p xmlns:a="http://schemas.openxmlformats.org/drawingml/2006/main">
             <a:pPr>
+              <a:buNone/>
               <a:defRPr sz="2250" b="0">
                 <a:solidFill>
                   <a:srgbClr val="182431"/>
@@ -10783,7 +11193,7 @@
                 <a:ea typeface="Arial"/>
                 <a:cs typeface="Arial"/>
               </a:rPr>
-              <a:t>Both presenters should explain their own work.</a:t>
+              <a:t>Git history records the implementation contributions.</a:t>
             </a:r>
           </a:p>
         </p:txBody>

</xml_diff>